<commit_message>
Coautoría de los tres, declaración de uso de IA y resumen de dos páginas
- Créditos reescritos: el proyecto es un trabajo conjunto de varios meses de
  Delfina Lafuente Veira, José Antonio Ondiviela y Miguel Ángel Domínguez, con
  la aportación de cada uno y sus cargos verificados en fuente oficial.
- Declaración de uso de inteligencia artificial conforme al artículo 50 del
  Reglamento (UE) 2024/1689, al principio del documento: qué hizo el sistema,
  qué hicieron las personas y cómo se controló.
- Condiciones de uso: se publica tal cual (as is), se recomienda su lectura y
  su uso, y se recomienda con la misma firmeza no copiarlo sin entenderlo.
- Nuevo entregable: resumen en dos páginas, con comprobación automática de que
  ocupa exactamente dos.
- La presentación pasa a un modelo de datos con dos renderizadores; su PDF sale
  de Chrome porque Keynote y PowerPoint no eran fiables por AppleScript.

Co-Authored-By: Claude Opus 5 <noreply@anthropic.com>
</commit_message>
<xml_diff>
--- a/docs/descargas/presentacion-ai-clauses.pptx
+++ b/docs/descargas/presentacion-ai-clauses.pptx
@@ -18,9 +18,10 @@
     <p:sldId id="266" r:id="rId12"/>
     <p:sldId id="267" r:id="rId13"/>
     <p:sldId id="268" r:id="rId14"/>
+    <p:sldId id="269" r:id="rId15"/>
   </p:sldIdLst>
   <p:notesMasterIdLst>
-    <p:notesMasterId r:id="rId15"/>
+    <p:notesMasterId r:id="rId16"/>
   </p:notesMasterIdLst>
   <p:sldSz cx="12192000" cy="6858000"/>
   <p:notesSz cx="6858000" cy="12192000"/>
@@ -890,6 +891,94 @@
             <a:fld id="{F7021451-1387-4CA6-816F-3879F97B5CBC}" type="slidenum">
               <a:rPr lang="en-US"/>
               <a:t>13</a:t>
+            </a:fld>
+            <a:endParaRPr lang="en-US"/>
+          </a:p>
+        </p:txBody>
+      </p:sp>
+    </p:spTree>
+    <p:extLst>
+      <p:ext uri="{BB962C8B-B14F-4D97-AF65-F5344CB8AC3E}">
+        <p14:creationId xmlns:p14="http://schemas.microsoft.com/office/powerpoint/2010/main" val="1024086991"/>
+      </p:ext>
+    </p:extLst>
+  </p:cSld>
+  <p:clrMapOvr>
+    <a:masterClrMapping/>
+  </p:clrMapOvr>
+</p:notes>
+</file>
+
+<file path=ppt/notesSlides/notesSlide14.xml><?xml version="1.0" encoding="utf-8"?>
+<p:notes xmlns:a="http://schemas.openxmlformats.org/drawingml/2006/main" xmlns:r="http://schemas.openxmlformats.org/officeDocument/2006/relationships" xmlns:p="http://schemas.openxmlformats.org/presentationml/2006/main">
+  <p:cSld>
+    <p:spTree>
+      <p:nvGrpSpPr>
+        <p:cNvPr id="1" name=""/>
+        <p:cNvGrpSpPr/>
+        <p:nvPr/>
+      </p:nvGrpSpPr>
+      <p:grpSpPr>
+        <a:xfrm>
+          <a:off x="0" y="0"/>
+          <a:ext cx="0" cy="0"/>
+          <a:chOff x="0" y="0"/>
+          <a:chExt cx="0" cy="0"/>
+        </a:xfrm>
+      </p:grpSpPr>
+      <p:sp>
+        <p:nvSpPr>
+          <p:cNvPr id="2" name="Slide Image Placeholder 1"/>
+          <p:cNvSpPr>
+            <a:spLocks noGrp="1" noRot="1" noChangeAspect="1"/>
+          </p:cNvSpPr>
+          <p:nvPr>
+            <p:ph type="sldImg"/>
+          </p:nvPr>
+        </p:nvSpPr>
+        <p:spPr/>
+      </p:sp>
+      <p:sp>
+        <p:nvSpPr>
+          <p:cNvPr id="3" name="Notes Placeholder 2"/>
+          <p:cNvSpPr>
+            <a:spLocks noGrp="1"/>
+          </p:cNvSpPr>
+          <p:nvPr>
+            <p:ph type="body" idx="1"/>
+          </p:nvPr>
+        </p:nvSpPr>
+        <p:spPr/>
+        <p:txBody>
+          <a:bodyPr/>
+          <a:lstStyle/>
+          <a:p>
+            <a:r>
+              <a:rPr lang="en-US" dirty="0"/>
+              <a:t/>
+            </a:r>
+            <a:endParaRPr lang="en-US" dirty="0"/>
+          </a:p>
+        </p:txBody>
+      </p:sp>
+      <p:sp>
+        <p:nvSpPr>
+          <p:cNvPr id="4" name="Slide Number Placeholder 3"/>
+          <p:cNvSpPr>
+            <a:spLocks noGrp="1"/>
+          </p:cNvSpPr>
+          <p:nvPr>
+            <p:ph type="sldNum" sz="quarter" idx="10"/>
+          </p:nvPr>
+        </p:nvSpPr>
+        <p:spPr/>
+        <p:txBody>
+          <a:bodyPr/>
+          <a:lstStyle/>
+          <a:p>
+            <a:fld id="{F7021451-1387-4CA6-816F-3879F97B5CBC}" type="slidenum">
+              <a:rPr lang="en-US"/>
+              <a:t>14</a:t>
             </a:fld>
             <a:endParaRPr lang="en-US"/>
           </a:p>
@@ -2139,7 +2228,7 @@
                 <a:ea typeface="Calibri" pitchFamily="34" charset="-122"/>
                 <a:cs typeface="Calibri" pitchFamily="34" charset="-120"/>
               </a:rPr>
-              <a:t>Miguel Ángel Domínguez Castellano</a:t>
+              <a:t>Delfina Lafuente Veira  ·  Dr. José Antonio Ondiviela García  ·  Miguel Ángel Domínguez Castellano</a:t>
             </a:r>
             <a:endParaRPr lang="en-US" sz="1500" dirty="0"/>
           </a:p>
@@ -3154,14 +3243,53 @@
       </p:sp>
       <p:sp>
         <p:nvSpPr>
-          <p:cNvPr id="3" name="Shape 1"/>
-          <p:cNvSpPr/>
-          <p:nvPr/>
-        </p:nvSpPr>
-        <p:spPr>
-          <a:xfrm>
-            <a:off x="822960" y="1645920"/>
-            <a:ext cx="82296" cy="1554480"/>
+          <p:cNvPr id="3" name="Text 1"/>
+          <p:cNvSpPr/>
+          <p:nvPr/>
+        </p:nvSpPr>
+        <p:spPr>
+          <a:xfrm>
+            <a:off x="822960" y="1371600"/>
+            <a:ext cx="10515600" cy="548640"/>
+          </a:xfrm>
+          <a:prstGeom prst="rect">
+            <a:avLst/>
+          </a:prstGeom>
+          <a:noFill/>
+          <a:ln/>
+        </p:spPr>
+        <p:txBody>
+          <a:bodyPr wrap="square" rtlCol="0" anchor="ctr"/>
+          <a:lstStyle/>
+          <a:p>
+            <a:pPr indent="0" marL="0">
+              <a:buNone/>
+            </a:pPr>
+            <a:r>
+              <a:rPr lang="en-US" sz="1600" dirty="0">
+                <a:solidFill>
+                  <a:srgbClr val="22201D"/>
+                </a:solidFill>
+                <a:latin typeface="Calibri" pitchFamily="34" charset="0"/>
+                <a:ea typeface="Calibri" pitchFamily="34" charset="-122"/>
+                <a:cs typeface="Calibri" pitchFamily="34" charset="-120"/>
+              </a:rPr>
+              <a:t>Un trabajo conjunto de varios meses entre tres personas, cada una desde su oficio, con el Ayuntamiento de Pozuelo de Alarcón como banco de pruebas real.</a:t>
+            </a:r>
+            <a:endParaRPr lang="en-US" sz="1600" dirty="0"/>
+          </a:p>
+        </p:txBody>
+      </p:sp>
+      <p:sp>
+        <p:nvSpPr>
+          <p:cNvPr id="4" name="Shape 2"/>
+          <p:cNvSpPr/>
+          <p:nvPr/>
+        </p:nvSpPr>
+        <p:spPr>
+          <a:xfrm>
+            <a:off x="822960" y="2057400"/>
+            <a:ext cx="82296" cy="1170432"/>
           </a:xfrm>
           <a:prstGeom prst="rect">
             <a:avLst/>
@@ -3174,30 +3302,30 @@
       </p:sp>
       <p:sp>
         <p:nvSpPr>
-          <p:cNvPr id="4" name="Text 2"/>
-          <p:cNvSpPr/>
-          <p:nvPr/>
-        </p:nvSpPr>
-        <p:spPr>
-          <a:xfrm>
-            <a:off x="1188720" y="1645920"/>
-            <a:ext cx="10058400" cy="457200"/>
-          </a:xfrm>
-          <a:prstGeom prst="rect">
-            <a:avLst/>
-          </a:prstGeom>
-          <a:noFill/>
-          <a:ln/>
-        </p:spPr>
-        <p:txBody>
-          <a:bodyPr wrap="square" rtlCol="0" anchor="ctr"/>
-          <a:lstStyle/>
-          <a:p>
-            <a:pPr indent="0" marL="0">
-              <a:buNone/>
-            </a:pPr>
-            <a:r>
-              <a:rPr lang="en-US" sz="2200" b="1" dirty="0">
+          <p:cNvPr id="5" name="Text 3"/>
+          <p:cNvSpPr/>
+          <p:nvPr/>
+        </p:nvSpPr>
+        <p:spPr>
+          <a:xfrm>
+            <a:off x="1188720" y="2057400"/>
+            <a:ext cx="10058400" cy="365760"/>
+          </a:xfrm>
+          <a:prstGeom prst="rect">
+            <a:avLst/>
+          </a:prstGeom>
+          <a:noFill/>
+          <a:ln/>
+        </p:spPr>
+        <p:txBody>
+          <a:bodyPr wrap="square" rtlCol="0" anchor="ctr"/>
+          <a:lstStyle/>
+          <a:p>
+            <a:pPr indent="0" marL="0">
+              <a:buNone/>
+            </a:pPr>
+            <a:r>
+              <a:rPr lang="en-US" sz="1800" b="1" dirty="0">
                 <a:solidFill>
                   <a:srgbClr val="1F3864"/>
                 </a:solidFill>
@@ -3207,53 +3335,75 @@
               </a:rPr>
               <a:t>Delfina Lafuente Veira</a:t>
             </a:r>
-            <a:endParaRPr lang="en-US" sz="2200" dirty="0"/>
-          </a:p>
-        </p:txBody>
-      </p:sp>
-      <p:sp>
-        <p:nvSpPr>
-          <p:cNvPr id="5" name="Text 3"/>
-          <p:cNvSpPr/>
-          <p:nvPr/>
-        </p:nvSpPr>
-        <p:spPr>
-          <a:xfrm>
-            <a:off x="1188720" y="2148840"/>
-            <a:ext cx="10058400" cy="685800"/>
-          </a:xfrm>
-          <a:prstGeom prst="rect">
-            <a:avLst/>
-          </a:prstGeom>
-          <a:noFill/>
-          <a:ln/>
-        </p:spPr>
-        <p:txBody>
-          <a:bodyPr wrap="square" rtlCol="0" anchor="ctr"/>
-          <a:lstStyle/>
-          <a:p>
-            <a:pPr indent="0" marL="0">
-              <a:buNone/>
-            </a:pPr>
-            <a:r>
-              <a:rPr lang="en-US" sz="1550" dirty="0">
-                <a:solidFill>
-                  <a:srgbClr val="22201D"/>
+            <a:endParaRPr lang="en-US" sz="1800" dirty="0"/>
+          </a:p>
+        </p:txBody>
+      </p:sp>
+      <p:sp>
+        <p:nvSpPr>
+          <p:cNvPr id="6" name="Text 4"/>
+          <p:cNvSpPr/>
+          <p:nvPr/>
+        </p:nvSpPr>
+        <p:spPr>
+          <a:xfrm>
+            <a:off x="1188720" y="2423160"/>
+            <a:ext cx="10058400" cy="292608"/>
+          </a:xfrm>
+          <a:prstGeom prst="rect">
+            <a:avLst/>
+          </a:prstGeom>
+          <a:noFill/>
+          <a:ln/>
+        </p:spPr>
+        <p:txBody>
+          <a:bodyPr wrap="square" rtlCol="0" anchor="ctr"/>
+          <a:lstStyle/>
+          <a:p>
+            <a:pPr indent="0" marL="0">
+              <a:buNone/>
+            </a:pPr>
+            <a:r>
+              <a:rPr lang="en-US" sz="1300" dirty="0">
+                <a:solidFill>
+                  <a:srgbClr val="6E6A63"/>
                 </a:solidFill>
                 <a:latin typeface="Calibri" pitchFamily="34" charset="0"/>
                 <a:ea typeface="Calibri" pitchFamily="34" charset="-122"/>
                 <a:cs typeface="Calibri" pitchFamily="34" charset="-120"/>
               </a:rPr>
-              <a:t>Concejal de Administración Digital, Calidad e Innovación</a:t>
-            </a:r>
-            <a:endParaRPr lang="en-US" sz="1550" dirty="0"/>
-          </a:p>
-          <a:p>
-            <a:pPr indent="0" marL="0">
-              <a:buNone/>
-            </a:pPr>
-            <a:r>
-              <a:rPr lang="en-US" sz="1550" dirty="0">
+              <a:t>Concejal de Administración Digital, Calidad e Innovación · Ayuntamiento de Pozuelo de Alarcón</a:t>
+            </a:r>
+            <a:endParaRPr lang="en-US" sz="1300" dirty="0"/>
+          </a:p>
+        </p:txBody>
+      </p:sp>
+      <p:sp>
+        <p:nvSpPr>
+          <p:cNvPr id="7" name="Text 5"/>
+          <p:cNvSpPr/>
+          <p:nvPr/>
+        </p:nvSpPr>
+        <p:spPr>
+          <a:xfrm>
+            <a:off x="1188720" y="2734056"/>
+            <a:ext cx="10058400" cy="502920"/>
+          </a:xfrm>
+          <a:prstGeom prst="rect">
+            <a:avLst/>
+          </a:prstGeom>
+          <a:noFill/>
+          <a:ln/>
+        </p:spPr>
+        <p:txBody>
+          <a:bodyPr wrap="square" rtlCol="0" anchor="ctr"/>
+          <a:lstStyle/>
+          <a:p>
+            <a:pPr indent="0" marL="0">
+              <a:buNone/>
+            </a:pPr>
+            <a:r>
+              <a:rPr lang="en-US" sz="1350" dirty="0">
                 <a:solidFill>
                   <a:srgbClr val="22201D"/>
                 </a:solidFill>
@@ -3261,21 +3411,41 @@
                 <a:ea typeface="Calibri" pitchFamily="34" charset="-122"/>
                 <a:cs typeface="Calibri" pitchFamily="34" charset="-120"/>
               </a:rPr>
-              <a:t>Ayuntamiento de Pozuelo de Alarcón</a:t>
-            </a:r>
-            <a:endParaRPr lang="en-US" sz="1550" dirty="0"/>
-          </a:p>
-        </p:txBody>
-      </p:sp>
-      <p:sp>
-        <p:nvSpPr>
-          <p:cNvPr id="6" name="Text 4"/>
-          <p:cNvSpPr/>
-          <p:nvPr/>
-        </p:nvSpPr>
-        <p:spPr>
-          <a:xfrm>
-            <a:off x="1188720" y="2788920"/>
+              <a:t>De ella nace el proyecto y suya es la primera redacción. Y suyo es el mérito menos visible: llevarlo a los servicios de contratación y jurídicos de su propio ayuntamiento y traer sus objeciones de vuelta enteras.</a:t>
+            </a:r>
+            <a:endParaRPr lang="en-US" sz="1350" dirty="0"/>
+          </a:p>
+        </p:txBody>
+      </p:sp>
+      <p:sp>
+        <p:nvSpPr>
+          <p:cNvPr id="8" name="Shape 6"/>
+          <p:cNvSpPr/>
+          <p:nvPr/>
+        </p:nvSpPr>
+        <p:spPr>
+          <a:xfrm>
+            <a:off x="822960" y="3429000"/>
+            <a:ext cx="82296" cy="1170432"/>
+          </a:xfrm>
+          <a:prstGeom prst="rect">
+            <a:avLst/>
+          </a:prstGeom>
+          <a:solidFill>
+            <a:srgbClr val="1F3864"/>
+          </a:solidFill>
+          <a:ln/>
+        </p:spPr>
+      </p:sp>
+      <p:sp>
+        <p:nvSpPr>
+          <p:cNvPr id="9" name="Text 7"/>
+          <p:cNvSpPr/>
+          <p:nvPr/>
+        </p:nvSpPr>
+        <p:spPr>
+          <a:xfrm>
+            <a:off x="1188720" y="3429000"/>
             <a:ext cx="10058400" cy="365760"/>
           </a:xfrm>
           <a:prstGeom prst="rect">
@@ -3292,7 +3462,46 @@
               <a:buNone/>
             </a:pPr>
             <a:r>
-              <a:rPr lang="en-US" sz="1400" i="1" dirty="0">
+              <a:rPr lang="en-US" sz="1800" b="1" dirty="0">
+                <a:solidFill>
+                  <a:srgbClr val="1F3864"/>
+                </a:solidFill>
+                <a:latin typeface="Georgia" pitchFamily="34" charset="0"/>
+                <a:ea typeface="Georgia" pitchFamily="34" charset="-122"/>
+                <a:cs typeface="Georgia" pitchFamily="34" charset="-120"/>
+              </a:rPr>
+              <a:t>Dr. José Antonio Ondiviela García</a:t>
+            </a:r>
+            <a:endParaRPr lang="en-US" sz="1800" dirty="0"/>
+          </a:p>
+        </p:txBody>
+      </p:sp>
+      <p:sp>
+        <p:nvSpPr>
+          <p:cNvPr id="10" name="Text 8"/>
+          <p:cNvSpPr/>
+          <p:nvPr/>
+        </p:nvSpPr>
+        <p:spPr>
+          <a:xfrm>
+            <a:off x="1188720" y="3794760"/>
+            <a:ext cx="10058400" cy="292608"/>
+          </a:xfrm>
+          <a:prstGeom prst="rect">
+            <a:avLst/>
+          </a:prstGeom>
+          <a:noFill/>
+          <a:ln/>
+        </p:spPr>
+        <p:txBody>
+          <a:bodyPr wrap="square" rtlCol="0" anchor="ctr"/>
+          <a:lstStyle/>
+          <a:p>
+            <a:pPr indent="0" marL="0">
+              <a:buNone/>
+            </a:pPr>
+            <a:r>
+              <a:rPr lang="en-US" sz="1300" dirty="0">
                 <a:solidFill>
                   <a:srgbClr val="6E6A63"/>
                 </a:solidFill>
@@ -3300,22 +3509,61 @@
                 <a:ea typeface="Calibri" pitchFamily="34" charset="-122"/>
                 <a:cs typeface="Calibri" pitchFamily="34" charset="-120"/>
               </a:rPr>
-              <a:t>Impulsora del proyecto y autora del clausulado original</a:t>
-            </a:r>
-            <a:endParaRPr lang="en-US" sz="1400" dirty="0"/>
-          </a:p>
-        </p:txBody>
-      </p:sp>
-      <p:sp>
-        <p:nvSpPr>
-          <p:cNvPr id="7" name="Shape 5"/>
-          <p:cNvSpPr/>
-          <p:nvPr/>
-        </p:nvSpPr>
-        <p:spPr>
-          <a:xfrm>
-            <a:off x="822960" y="3474720"/>
-            <a:ext cx="82296" cy="1554480"/>
+              <a:t>Profesor e investigador de la Escuela Politécnica Superior · Universidad Francisco de Vitoria</a:t>
+            </a:r>
+            <a:endParaRPr lang="en-US" sz="1300" dirty="0"/>
+          </a:p>
+        </p:txBody>
+      </p:sp>
+      <p:sp>
+        <p:nvSpPr>
+          <p:cNvPr id="11" name="Text 9"/>
+          <p:cNvSpPr/>
+          <p:nvPr/>
+        </p:nvSpPr>
+        <p:spPr>
+          <a:xfrm>
+            <a:off x="1188720" y="4105656"/>
+            <a:ext cx="10058400" cy="502920"/>
+          </a:xfrm>
+          <a:prstGeom prst="rect">
+            <a:avLst/>
+          </a:prstGeom>
+          <a:noFill/>
+          <a:ln/>
+        </p:spPr>
+        <p:txBody>
+          <a:bodyPr wrap="square" rtlCol="0" anchor="ctr"/>
+          <a:lstStyle/>
+          <a:p>
+            <a:pPr indent="0" marL="0">
+              <a:buNone/>
+            </a:pPr>
+            <a:r>
+              <a:rPr lang="en-US" sz="1350" dirty="0">
+                <a:solidFill>
+                  <a:srgbClr val="22201D"/>
+                </a:solidFill>
+                <a:latin typeface="Calibri" pitchFamily="34" charset="0"/>
+                <a:ea typeface="Calibri" pitchFamily="34" charset="-122"/>
+                <a:cs typeface="Calibri" pitchFamily="34" charset="-120"/>
+              </a:rPr>
+              <a:t>La mirada del mercado: qué se le puede pedir de verdad a un fabricante de software y qué hará que no se presente. Suya es la idea que resuelve el problema de fondo.</a:t>
+            </a:r>
+            <a:endParaRPr lang="en-US" sz="1350" dirty="0"/>
+          </a:p>
+        </p:txBody>
+      </p:sp>
+      <p:sp>
+        <p:nvSpPr>
+          <p:cNvPr id="12" name="Shape 10"/>
+          <p:cNvSpPr/>
+          <p:nvPr/>
+        </p:nvSpPr>
+        <p:spPr>
+          <a:xfrm>
+            <a:off x="822960" y="4800600"/>
+            <a:ext cx="82296" cy="1170432"/>
           </a:xfrm>
           <a:prstGeom prst="rect">
             <a:avLst/>
@@ -3328,30 +3576,30 @@
       </p:sp>
       <p:sp>
         <p:nvSpPr>
-          <p:cNvPr id="8" name="Text 6"/>
-          <p:cNvSpPr/>
-          <p:nvPr/>
-        </p:nvSpPr>
-        <p:spPr>
-          <a:xfrm>
-            <a:off x="1188720" y="3474720"/>
-            <a:ext cx="10058400" cy="457200"/>
-          </a:xfrm>
-          <a:prstGeom prst="rect">
-            <a:avLst/>
-          </a:prstGeom>
-          <a:noFill/>
-          <a:ln/>
-        </p:spPr>
-        <p:txBody>
-          <a:bodyPr wrap="square" rtlCol="0" anchor="ctr"/>
-          <a:lstStyle/>
-          <a:p>
-            <a:pPr indent="0" marL="0">
-              <a:buNone/>
-            </a:pPr>
-            <a:r>
-              <a:rPr lang="en-US" sz="2200" b="1" dirty="0">
+          <p:cNvPr id="13" name="Text 11"/>
+          <p:cNvSpPr/>
+          <p:nvPr/>
+        </p:nvSpPr>
+        <p:spPr>
+          <a:xfrm>
+            <a:off x="1188720" y="4800600"/>
+            <a:ext cx="10058400" cy="365760"/>
+          </a:xfrm>
+          <a:prstGeom prst="rect">
+            <a:avLst/>
+          </a:prstGeom>
+          <a:noFill/>
+          <a:ln/>
+        </p:spPr>
+        <p:txBody>
+          <a:bodyPr wrap="square" rtlCol="0" anchor="ctr"/>
+          <a:lstStyle/>
+          <a:p>
+            <a:pPr indent="0" marL="0">
+              <a:buNone/>
+            </a:pPr>
+            <a:r>
+              <a:rPr lang="en-US" sz="1800" b="1" dirty="0">
                 <a:solidFill>
                   <a:srgbClr val="1F3864"/>
                 </a:solidFill>
@@ -3359,55 +3607,77 @@
                 <a:ea typeface="Georgia" pitchFamily="34" charset="-122"/>
                 <a:cs typeface="Georgia" pitchFamily="34" charset="-120"/>
               </a:rPr>
-              <a:t>Dr. José Antonio Ondiviela García</a:t>
-            </a:r>
-            <a:endParaRPr lang="en-US" sz="2200" dirty="0"/>
-          </a:p>
-        </p:txBody>
-      </p:sp>
-      <p:sp>
-        <p:nvSpPr>
-          <p:cNvPr id="9" name="Text 7"/>
-          <p:cNvSpPr/>
-          <p:nvPr/>
-        </p:nvSpPr>
-        <p:spPr>
-          <a:xfrm>
-            <a:off x="1188720" y="3977640"/>
-            <a:ext cx="10058400" cy="685800"/>
-          </a:xfrm>
-          <a:prstGeom prst="rect">
-            <a:avLst/>
-          </a:prstGeom>
-          <a:noFill/>
-          <a:ln/>
-        </p:spPr>
-        <p:txBody>
-          <a:bodyPr wrap="square" rtlCol="0" anchor="ctr"/>
-          <a:lstStyle/>
-          <a:p>
-            <a:pPr indent="0" marL="0">
-              <a:buNone/>
-            </a:pPr>
-            <a:r>
-              <a:rPr lang="en-US" sz="1550" dirty="0">
-                <a:solidFill>
-                  <a:srgbClr val="22201D"/>
+              <a:t>Miguel Ángel Domínguez Castellano</a:t>
+            </a:r>
+            <a:endParaRPr lang="en-US" sz="1800" dirty="0"/>
+          </a:p>
+        </p:txBody>
+      </p:sp>
+      <p:sp>
+        <p:nvSpPr>
+          <p:cNvPr id="14" name="Text 12"/>
+          <p:cNvSpPr/>
+          <p:nvPr/>
+        </p:nvSpPr>
+        <p:spPr>
+          <a:xfrm>
+            <a:off x="1188720" y="5166360"/>
+            <a:ext cx="10058400" cy="292608"/>
+          </a:xfrm>
+          <a:prstGeom prst="rect">
+            <a:avLst/>
+          </a:prstGeom>
+          <a:noFill/>
+          <a:ln/>
+        </p:spPr>
+        <p:txBody>
+          <a:bodyPr wrap="square" rtlCol="0" anchor="ctr"/>
+          <a:lstStyle/>
+          <a:p>
+            <a:pPr indent="0" marL="0">
+              <a:buNone/>
+            </a:pPr>
+            <a:r>
+              <a:rPr lang="en-US" sz="1300" dirty="0">
+                <a:solidFill>
+                  <a:srgbClr val="6E6A63"/>
                 </a:solidFill>
                 <a:latin typeface="Calibri" pitchFamily="34" charset="0"/>
                 <a:ea typeface="Calibri" pitchFamily="34" charset="-122"/>
                 <a:cs typeface="Calibri" pitchFamily="34" charset="-120"/>
               </a:rPr>
-              <a:t>Profesor de la Escuela Politécnica Superior e investigador</a:t>
-            </a:r>
-            <a:endParaRPr lang="en-US" sz="1550" dirty="0"/>
-          </a:p>
-          <a:p>
-            <a:pPr indent="0" marL="0">
-              <a:buNone/>
-            </a:pPr>
-            <a:r>
-              <a:rPr lang="en-US" sz="1550" dirty="0">
+              <a:t>CEO de Add4u · Presidente de Alastria · Presidente del Clúster de Blockchain de la Comunidad de Madrid</a:t>
+            </a:r>
+            <a:endParaRPr lang="en-US" sz="1300" dirty="0"/>
+          </a:p>
+        </p:txBody>
+      </p:sp>
+      <p:sp>
+        <p:nvSpPr>
+          <p:cNvPr id="15" name="Text 13"/>
+          <p:cNvSpPr/>
+          <p:nvPr/>
+        </p:nvSpPr>
+        <p:spPr>
+          <a:xfrm>
+            <a:off x="1188720" y="5477256"/>
+            <a:ext cx="10058400" cy="502920"/>
+          </a:xfrm>
+          <a:prstGeom prst="rect">
+            <a:avLst/>
+          </a:prstGeom>
+          <a:noFill/>
+          <a:ln/>
+        </p:spPr>
+        <p:txBody>
+          <a:bodyPr wrap="square" rtlCol="0" anchor="ctr"/>
+          <a:lstStyle/>
+          <a:p>
+            <a:pPr indent="0" marL="0">
+              <a:buNone/>
+            </a:pPr>
+            <a:r>
+              <a:rPr lang="en-US" sz="1350" dirty="0">
                 <a:solidFill>
                   <a:srgbClr val="22201D"/>
                 </a:solidFill>
@@ -3415,38 +3685,38 @@
                 <a:ea typeface="Calibri" pitchFamily="34" charset="-122"/>
                 <a:cs typeface="Calibri" pitchFamily="34" charset="-120"/>
               </a:rPr>
-              <a:t>Universidad Francisco de Vitoria</a:t>
-            </a:r>
-            <a:endParaRPr lang="en-US" sz="1550" dirty="0"/>
-          </a:p>
-        </p:txBody>
-      </p:sp>
-      <p:sp>
-        <p:nvSpPr>
-          <p:cNvPr id="10" name="Text 8"/>
-          <p:cNvSpPr/>
-          <p:nvPr/>
-        </p:nvSpPr>
-        <p:spPr>
-          <a:xfrm>
-            <a:off x="1188720" y="4617720"/>
-            <a:ext cx="10058400" cy="365760"/>
-          </a:xfrm>
-          <a:prstGeom prst="rect">
-            <a:avLst/>
-          </a:prstGeom>
-          <a:noFill/>
-          <a:ln/>
-        </p:spPr>
-        <p:txBody>
-          <a:bodyPr wrap="square" rtlCol="0" anchor="ctr"/>
-          <a:lstStyle/>
-          <a:p>
-            <a:pPr indent="0" marL="0">
-              <a:buNone/>
-            </a:pPr>
-            <a:r>
-              <a:rPr lang="en-US" sz="1400" i="1" dirty="0">
+              <a:t>La perspectiva de quien conoce las dos orillas: la de quien redacta pliegos y la de quien se presenta a ellos. Asume la responsabilidad editorial de la publicación.</a:t>
+            </a:r>
+            <a:endParaRPr lang="en-US" sz="1350" dirty="0"/>
+          </a:p>
+        </p:txBody>
+      </p:sp>
+      <p:sp>
+        <p:nvSpPr>
+          <p:cNvPr id="16" name="Text 14"/>
+          <p:cNvSpPr/>
+          <p:nvPr/>
+        </p:nvSpPr>
+        <p:spPr>
+          <a:xfrm>
+            <a:off x="822960" y="5806440"/>
+            <a:ext cx="10515600" cy="731520"/>
+          </a:xfrm>
+          <a:prstGeom prst="rect">
+            <a:avLst/>
+          </a:prstGeom>
+          <a:noFill/>
+          <a:ln/>
+        </p:spPr>
+        <p:txBody>
+          <a:bodyPr wrap="square" rtlCol="0" anchor="ctr"/>
+          <a:lstStyle/>
+          <a:p>
+            <a:pPr indent="0" marL="0">
+              <a:buNone/>
+            </a:pPr>
+            <a:r>
+              <a:rPr lang="en-US" sz="1350" i="1" dirty="0">
                 <a:solidFill>
                   <a:srgbClr val="6E6A63"/>
                 </a:solidFill>
@@ -3454,87 +3724,9 @@
                 <a:ea typeface="Calibri" pitchFamily="34" charset="-122"/>
                 <a:cs typeface="Calibri" pitchFamily="34" charset="-120"/>
               </a:rPr>
-              <a:t>Revisión técnica y de mercado</a:t>
-            </a:r>
-            <a:endParaRPr lang="en-US" sz="1400" dirty="0"/>
-          </a:p>
-        </p:txBody>
-      </p:sp>
-      <p:sp>
-        <p:nvSpPr>
-          <p:cNvPr id="11" name="Text 9"/>
-          <p:cNvSpPr/>
-          <p:nvPr/>
-        </p:nvSpPr>
-        <p:spPr>
-          <a:xfrm>
-            <a:off x="822960" y="5440680"/>
-            <a:ext cx="10515600" cy="640080"/>
-          </a:xfrm>
-          <a:prstGeom prst="rect">
-            <a:avLst/>
-          </a:prstGeom>
-          <a:noFill/>
-          <a:ln/>
-        </p:spPr>
-        <p:txBody>
-          <a:bodyPr wrap="square" rtlCol="0" anchor="ctr"/>
-          <a:lstStyle/>
-          <a:p>
-            <a:pPr indent="0" marL="0">
-              <a:buNone/>
-            </a:pPr>
-            <a:r>
-              <a:rPr lang="en-US" sz="1500" dirty="0">
-                <a:solidFill>
-                  <a:srgbClr val="22201D"/>
-                </a:solidFill>
-                <a:latin typeface="Calibri" pitchFamily="34" charset="0"/>
-                <a:ea typeface="Calibri" pitchFamily="34" charset="-122"/>
-                <a:cs typeface="Calibri" pitchFamily="34" charset="-120"/>
-              </a:rPr>
-              <a:t>El clausulado incorpora las observaciones del área de contratación del Ayuntamiento de Pozuelo de Alarcón, que son las que dieron forma a esta versión.</a:t>
-            </a:r>
-            <a:endParaRPr lang="en-US" sz="1500" dirty="0"/>
-          </a:p>
-        </p:txBody>
-      </p:sp>
-      <p:sp>
-        <p:nvSpPr>
-          <p:cNvPr id="12" name="Text 10"/>
-          <p:cNvSpPr/>
-          <p:nvPr/>
-        </p:nvSpPr>
-        <p:spPr>
-          <a:xfrm>
-            <a:off x="822960" y="5989320"/>
-            <a:ext cx="10515600" cy="548640"/>
-          </a:xfrm>
-          <a:prstGeom prst="rect">
-            <a:avLst/>
-          </a:prstGeom>
-          <a:noFill/>
-          <a:ln/>
-        </p:spPr>
-        <p:txBody>
-          <a:bodyPr wrap="square" rtlCol="0" anchor="ctr"/>
-          <a:lstStyle/>
-          <a:p>
-            <a:pPr indent="0" marL="0">
-              <a:buNone/>
-            </a:pPr>
-            <a:r>
-              <a:rPr lang="en-US" sz="1400" i="1" dirty="0">
-                <a:solidFill>
-                  <a:srgbClr val="6E6A63"/>
-                </a:solidFill>
-                <a:latin typeface="Calibri" pitchFamily="34" charset="0"/>
-                <a:ea typeface="Calibri" pitchFamily="34" charset="-122"/>
-                <a:cs typeface="Calibri" pitchFamily="34" charset="-120"/>
-              </a:rPr>
-              <a:t>Publicado y firmado por Miguel Ángel Domínguez Castellano.</a:t>
-            </a:r>
-            <a:endParaRPr lang="en-US" sz="1400" dirty="0"/>
+              <a:t>El área de contratación del Ayuntamiento de Pozuelo de Alarcón no figura como autora y sin embargo ha determinado la forma del documento más que ninguna otra aportación: sus tres objeciones son la razón de ser de esta versión.</a:t>
+            </a:r>
+            <a:endParaRPr lang="en-US" sz="1350" dirty="0"/>
           </a:p>
         </p:txBody>
       </p:sp>
@@ -3549,6 +3741,355 @@
 <file path=ppt/slides/slide13.xml><?xml version="1.0" encoding="utf-8"?>
 <p:sld xmlns:a="http://schemas.openxmlformats.org/drawingml/2006/main" xmlns:r="http://schemas.openxmlformats.org/officeDocument/2006/relationships" xmlns:p="http://schemas.openxmlformats.org/presentationml/2006/main">
   <p:cSld name="Slide 13">
+    <p:bg>
+      <p:bgPr>
+        <a:solidFill>
+          <a:srgbClr val="FFFFFF"/>
+        </a:solidFill>
+      </p:bgPr>
+    </p:bg>
+    <p:spTree>
+      <p:nvGrpSpPr>
+        <p:cNvPr id="1" name=""/>
+        <p:cNvGrpSpPr/>
+        <p:nvPr/>
+      </p:nvGrpSpPr>
+      <p:grpSpPr>
+        <a:xfrm>
+          <a:off x="0" y="0"/>
+          <a:ext cx="0" cy="0"/>
+          <a:chOff x="0" y="0"/>
+          <a:chExt cx="0" cy="0"/>
+        </a:xfrm>
+      </p:grpSpPr>
+      <p:sp>
+        <p:nvSpPr>
+          <p:cNvPr id="2" name="Text 0"/>
+          <p:cNvSpPr/>
+          <p:nvPr/>
+        </p:nvSpPr>
+        <p:spPr>
+          <a:xfrm>
+            <a:off x="822960" y="502920"/>
+            <a:ext cx="10515600" cy="822960"/>
+          </a:xfrm>
+          <a:prstGeom prst="rect">
+            <a:avLst/>
+          </a:prstGeom>
+          <a:noFill/>
+          <a:ln/>
+        </p:spPr>
+        <p:txBody>
+          <a:bodyPr wrap="square" rtlCol="0" anchor="ctr"/>
+          <a:lstStyle/>
+          <a:p>
+            <a:pPr indent="0" marL="0">
+              <a:buNone/>
+            </a:pPr>
+            <a:r>
+              <a:rPr lang="en-US" sz="3600" b="1" dirty="0">
+                <a:solidFill>
+                  <a:srgbClr val="1F3864"/>
+                </a:solidFill>
+                <a:latin typeface="Georgia" pitchFamily="34" charset="0"/>
+                <a:ea typeface="Georgia" pitchFamily="34" charset="-122"/>
+                <a:cs typeface="Georgia" pitchFamily="34" charset="-120"/>
+              </a:rPr>
+              <a:t>Uso de inteligencia artificial, y cómo debe usarse esto</a:t>
+            </a:r>
+            <a:endParaRPr lang="en-US" sz="3600" dirty="0"/>
+          </a:p>
+        </p:txBody>
+      </p:sp>
+      <p:sp>
+        <p:nvSpPr>
+          <p:cNvPr id="3" name="Shape 1"/>
+          <p:cNvSpPr/>
+          <p:nvPr/>
+        </p:nvSpPr>
+        <p:spPr>
+          <a:xfrm>
+            <a:off x="822960" y="1417320"/>
+            <a:ext cx="10515600" cy="1783080"/>
+          </a:xfrm>
+          <a:prstGeom prst="roundRect">
+            <a:avLst>
+              <a:gd name="adj" fmla="val 5128"/>
+            </a:avLst>
+          </a:prstGeom>
+          <a:solidFill>
+            <a:srgbClr val="EDF1F8"/>
+          </a:solidFill>
+          <a:ln/>
+        </p:spPr>
+      </p:sp>
+      <p:sp>
+        <p:nvSpPr>
+          <p:cNvPr id="4" name="Text 2"/>
+          <p:cNvSpPr/>
+          <p:nvPr/>
+        </p:nvSpPr>
+        <p:spPr>
+          <a:xfrm>
+            <a:off x="1188720" y="1645920"/>
+            <a:ext cx="9784080" cy="365760"/>
+          </a:xfrm>
+          <a:prstGeom prst="rect">
+            <a:avLst/>
+          </a:prstGeom>
+          <a:noFill/>
+          <a:ln/>
+        </p:spPr>
+        <p:txBody>
+          <a:bodyPr wrap="square" rtlCol="0" anchor="ctr"/>
+          <a:lstStyle/>
+          <a:p>
+            <a:pPr indent="0" marL="0">
+              <a:buNone/>
+            </a:pPr>
+            <a:r>
+              <a:rPr lang="en-US" sz="1500" b="1" dirty="0">
+                <a:solidFill>
+                  <a:srgbClr val="1F3864"/>
+                </a:solidFill>
+                <a:latin typeface="Calibri" pitchFamily="34" charset="0"/>
+                <a:ea typeface="Calibri" pitchFamily="34" charset="-122"/>
+                <a:cs typeface="Calibri" pitchFamily="34" charset="-120"/>
+              </a:rPr>
+              <a:t>En la elaboración de este documento se han utilizado sistemas de inteligencia artificial:</a:t>
+            </a:r>
+            <a:endParaRPr lang="en-US" sz="1500" dirty="0"/>
+          </a:p>
+        </p:txBody>
+      </p:sp>
+      <p:sp>
+        <p:nvSpPr>
+          <p:cNvPr id="5" name="Text 3"/>
+          <p:cNvSpPr/>
+          <p:nvPr/>
+        </p:nvSpPr>
+        <p:spPr>
+          <a:xfrm>
+            <a:off x="1188720" y="2011680"/>
+            <a:ext cx="9784080" cy="1051560"/>
+          </a:xfrm>
+          <a:prstGeom prst="rect">
+            <a:avLst/>
+          </a:prstGeom>
+          <a:noFill/>
+          <a:ln/>
+        </p:spPr>
+        <p:txBody>
+          <a:bodyPr wrap="square" rtlCol="0" anchor="ctr"/>
+          <a:lstStyle/>
+          <a:p>
+            <a:pPr indent="0" marL="0">
+              <a:buNone/>
+            </a:pPr>
+            <a:r>
+              <a:rPr lang="en-US" sz="1450" dirty="0">
+                <a:solidFill>
+                  <a:srgbClr val="22201D"/>
+                </a:solidFill>
+                <a:latin typeface="Calibri" pitchFamily="34" charset="0"/>
+                <a:ea typeface="Calibri" pitchFamily="34" charset="-122"/>
+                <a:cs typeface="Calibri" pitchFamily="34" charset="-120"/>
+              </a:rPr>
+              <a:t>el clon digital («second brain») de Miguel Ángel Domínguez, determinante en la recuperación del material disperso, la investigación jurídica, la verificación de las fuentes, la crítica adversarial del texto y la redacción de los borradores. Las decisiones, el criterio jurídico y la responsabilidad son de las personas que lo firman.</a:t>
+            </a:r>
+            <a:endParaRPr lang="en-US" sz="1450" dirty="0"/>
+          </a:p>
+        </p:txBody>
+      </p:sp>
+      <p:sp>
+        <p:nvSpPr>
+          <p:cNvPr id="6" name="Text 4"/>
+          <p:cNvSpPr/>
+          <p:nvPr/>
+        </p:nvSpPr>
+        <p:spPr>
+          <a:xfrm>
+            <a:off x="822960" y="3337560"/>
+            <a:ext cx="10515600" cy="685800"/>
+          </a:xfrm>
+          <a:prstGeom prst="rect">
+            <a:avLst/>
+          </a:prstGeom>
+          <a:noFill/>
+          <a:ln/>
+        </p:spPr>
+        <p:txBody>
+          <a:bodyPr wrap="square" rtlCol="0" anchor="ctr"/>
+          <a:lstStyle/>
+          <a:p>
+            <a:pPr indent="0" marL="0">
+              <a:buNone/>
+            </a:pPr>
+            <a:r>
+              <a:rPr lang="en-US" sz="1400" i="1" dirty="0">
+                <a:solidFill>
+                  <a:srgbClr val="6E6A63"/>
+                </a:solidFill>
+                <a:latin typeface="Calibri" pitchFamily="34" charset="0"/>
+                <a:ea typeface="Calibri" pitchFamily="34" charset="-122"/>
+                <a:cs typeface="Calibri" pitchFamily="34" charset="-120"/>
+              </a:rPr>
+              <a:t>Se declara aunque no sea obligatorio: el art. 50.4 del Reglamento (UE) 2024/1689 exime de divulgarlo cuando hay revisión humana y responsabilidad editorial. Se divulga igualmente, porque un documento que exige transparencia de IA no puede ocultarla en sí mismo.</a:t>
+            </a:r>
+            <a:endParaRPr lang="en-US" sz="1400" dirty="0"/>
+          </a:p>
+        </p:txBody>
+      </p:sp>
+      <p:sp>
+        <p:nvSpPr>
+          <p:cNvPr id="7" name="Shape 5"/>
+          <p:cNvSpPr/>
+          <p:nvPr/>
+        </p:nvSpPr>
+        <p:spPr>
+          <a:xfrm>
+            <a:off x="822960" y="4160520"/>
+            <a:ext cx="10515600" cy="1600200"/>
+          </a:xfrm>
+          <a:prstGeom prst="roundRect">
+            <a:avLst>
+              <a:gd name="adj" fmla="val 5714"/>
+            </a:avLst>
+          </a:prstGeom>
+          <a:solidFill>
+            <a:srgbClr val="FDF6E6"/>
+          </a:solidFill>
+          <a:ln/>
+        </p:spPr>
+      </p:sp>
+      <p:sp>
+        <p:nvSpPr>
+          <p:cNvPr id="8" name="Text 6"/>
+          <p:cNvSpPr/>
+          <p:nvPr/>
+        </p:nvSpPr>
+        <p:spPr>
+          <a:xfrm>
+            <a:off x="1188720" y="4389120"/>
+            <a:ext cx="9784080" cy="457200"/>
+          </a:xfrm>
+          <a:prstGeom prst="rect">
+            <a:avLst/>
+          </a:prstGeom>
+          <a:noFill/>
+          <a:ln/>
+        </p:spPr>
+        <p:txBody>
+          <a:bodyPr wrap="square" rtlCol="0" anchor="ctr"/>
+          <a:lstStyle/>
+          <a:p>
+            <a:pPr indent="0" marL="0">
+              <a:buNone/>
+            </a:pPr>
+            <a:r>
+              <a:rPr lang="en-US" sz="1800" b="1" dirty="0">
+                <a:solidFill>
+                  <a:srgbClr val="22201D"/>
+                </a:solidFill>
+                <a:latin typeface="Georgia" pitchFamily="34" charset="0"/>
+                <a:ea typeface="Georgia" pitchFamily="34" charset="-122"/>
+                <a:cs typeface="Georgia" pitchFamily="34" charset="-120"/>
+              </a:rPr>
+              <a:t>Se publica «tal cual» (as is). Se recomienda su lectura y su uso — y con la misma firmeza, NO copiarlo sin entenderlo.</a:t>
+            </a:r>
+            <a:endParaRPr lang="en-US" sz="1800" dirty="0"/>
+          </a:p>
+        </p:txBody>
+      </p:sp>
+      <p:sp>
+        <p:nvSpPr>
+          <p:cNvPr id="9" name="Text 7"/>
+          <p:cNvSpPr/>
+          <p:nvPr/>
+        </p:nvSpPr>
+        <p:spPr>
+          <a:xfrm>
+            <a:off x="1188720" y="4892040"/>
+            <a:ext cx="9784080" cy="777240"/>
+          </a:xfrm>
+          <a:prstGeom prst="rect">
+            <a:avLst/>
+          </a:prstGeom>
+          <a:noFill/>
+          <a:ln/>
+        </p:spPr>
+        <p:txBody>
+          <a:bodyPr wrap="square" rtlCol="0" anchor="ctr"/>
+          <a:lstStyle/>
+          <a:p>
+            <a:pPr indent="0" marL="0">
+              <a:buNone/>
+            </a:pPr>
+            <a:r>
+              <a:rPr lang="en-US" sz="1450" dirty="0">
+                <a:solidFill>
+                  <a:srgbClr val="22201D"/>
+                </a:solidFill>
+                <a:latin typeface="Calibri" pitchFamily="34" charset="0"/>
+                <a:ea typeface="Calibri" pitchFamily="34" charset="-122"/>
+                <a:cs typeface="Calibri" pitchFamily="34" charset="-120"/>
+              </a:rPr>
+              <a:t>Una cláusula copiada sin necesidad acreditada no protege: añade un motivo de recurso. Una exigencia copiada sin contrastar con el mercado no es más ambiciosa, es más restrictiva. Una obligación que nadie verifica es peor que no tenerla.</a:t>
+            </a:r>
+            <a:endParaRPr lang="en-US" sz="1450" dirty="0"/>
+          </a:p>
+        </p:txBody>
+      </p:sp>
+      <p:sp>
+        <p:nvSpPr>
+          <p:cNvPr id="10" name="Text 8"/>
+          <p:cNvSpPr/>
+          <p:nvPr/>
+        </p:nvSpPr>
+        <p:spPr>
+          <a:xfrm>
+            <a:off x="822960" y="5989320"/>
+            <a:ext cx="10515600" cy="548640"/>
+          </a:xfrm>
+          <a:prstGeom prst="rect">
+            <a:avLst/>
+          </a:prstGeom>
+          <a:noFill/>
+          <a:ln/>
+        </p:spPr>
+        <p:txBody>
+          <a:bodyPr wrap="square" rtlCol="0" anchor="ctr"/>
+          <a:lstStyle/>
+          <a:p>
+            <a:pPr indent="0" marL="0">
+              <a:buNone/>
+            </a:pPr>
+            <a:r>
+              <a:rPr lang="en-US" sz="1400" i="1" dirty="0">
+                <a:solidFill>
+                  <a:srgbClr val="6E6A63"/>
+                </a:solidFill>
+                <a:latin typeface="Calibri" pitchFamily="34" charset="0"/>
+                <a:ea typeface="Calibri" pitchFamily="34" charset="-122"/>
+                <a:cs typeface="Calibri" pitchFamily="34" charset="-120"/>
+              </a:rPr>
+              <a:t>No es asesoramiento legal, y no sustituye a los informes preceptivos de ninguna administración.</a:t>
+            </a:r>
+            <a:endParaRPr lang="en-US" sz="1400" dirty="0"/>
+          </a:p>
+        </p:txBody>
+      </p:sp>
+    </p:spTree>
+  </p:cSld>
+  <p:clrMapOvr>
+    <a:masterClrMapping/>
+  </p:clrMapOvr>
+</p:sld>
+</file>
+
+<file path=ppt/slides/slide14.xml><?xml version="1.0" encoding="utf-8"?>
+<p:sld xmlns:a="http://schemas.openxmlformats.org/drawingml/2006/main" xmlns:r="http://schemas.openxmlformats.org/officeDocument/2006/relationships" xmlns:p="http://schemas.openxmlformats.org/presentationml/2006/main">
+  <p:cSld name="Slide 14">
     <p:bg>
       <p:bgPr>
         <a:solidFill>

</xml_diff>

<commit_message>
Enlaces a las referencias de los tres autores
- Delfina Lafuente Veira: su trayectoria oficial en pozuelodealarcon.org
- José Antonio Ondiviela García: su perfil en ufv.es
- Miguel Ángel Domínguez Castellano: miguelangeldominguez.info

En el documento, el resumen, la web, el Word y la presentación. Las tres URL
comprobadas antes de ponerlas.

De paso, el generador de Word hace ahora hipervínculos de verdad: el parser de
estilos en línea era plano y se tragaba los enlaces dentro de la negrita, que es
exactamente el caso de los créditos, así que salían azules pero muertos.

Co-Authored-By: Claude Opus 5 <noreply@anthropic.com>
</commit_message>
<xml_diff>
--- a/docs/descargas/presentacion-ai-clauses.pptx
+++ b/docs/descargas/presentacion-ai-clauses.pptx
@@ -3372,7 +3372,7 @@
                 <a:ea typeface="Calibri" pitchFamily="34" charset="-122"/>
                 <a:cs typeface="Calibri" pitchFamily="34" charset="-120"/>
               </a:rPr>
-              <a:t>Concejal de Administración Digital, Calidad e Innovación · Ayuntamiento de Pozuelo de Alarcón</a:t>
+              <a:t>Concejal de Administración Digital, Calidad e Innovación · Ayuntamiento de Pozuelo de Alarcón  ·  pozuelodealarcon.org</a:t>
             </a:r>
             <a:endParaRPr lang="en-US" sz="1300" dirty="0"/>
           </a:p>
@@ -3509,7 +3509,7 @@
                 <a:ea typeface="Calibri" pitchFamily="34" charset="-122"/>
                 <a:cs typeface="Calibri" pitchFamily="34" charset="-120"/>
               </a:rPr>
-              <a:t>Profesor e investigador de la Escuela Politécnica Superior · Universidad Francisco de Vitoria</a:t>
+              <a:t>Profesor e investigador de la Escuela Politécnica Superior · Universidad Francisco de Vitoria  ·  ufv.es</a:t>
             </a:r>
             <a:endParaRPr lang="en-US" sz="1300" dirty="0"/>
           </a:p>
@@ -3646,7 +3646,7 @@
                 <a:ea typeface="Calibri" pitchFamily="34" charset="-122"/>
                 <a:cs typeface="Calibri" pitchFamily="34" charset="-120"/>
               </a:rPr>
-              <a:t>CEO de Add4u · Presidente de Alastria · Presidente del Clúster de Blockchain de la Comunidad de Madrid</a:t>
+              <a:t>CEO de Add4u · Presidente de Alastria · Presidente del Clúster de Blockchain de la Comunidad de Madrid  ·  miguelangeldominguez.info</a:t>
             </a:r>
             <a:endParaRPr lang="en-US" sz="1300" dirty="0"/>
           </a:p>

</xml_diff>

<commit_message>
cdx: añade guía de revisión y autoría técnica
</commit_message>
<xml_diff>
--- a/docs/descargas/presentacion-ai-clauses.pptx
+++ b/docs/descargas/presentacion-ai-clauses.pptx
@@ -2722,12 +2722,12 @@
         </p:nvSpPr>
         <p:spPr>
           <a:xfrm>
-            <a:off x="822960" y="1600200"/>
-            <a:ext cx="10515600" cy="1234440"/>
+            <a:off x="822960" y="1417320"/>
+            <a:ext cx="10515600" cy="987552"/>
           </a:xfrm>
           <a:prstGeom prst="roundRect">
             <a:avLst>
-              <a:gd name="adj" fmla="val 7407"/>
+              <a:gd name="adj" fmla="val 9259"/>
             </a:avLst>
           </a:prstGeom>
           <a:solidFill>
@@ -2744,24 +2744,24 @@
         </p:nvSpPr>
         <p:spPr>
           <a:xfrm>
-            <a:off x="1097280" y="1737360"/>
-            <a:ext cx="3108960" cy="960120"/>
-          </a:xfrm>
-          <a:prstGeom prst="rect">
-            <a:avLst/>
-          </a:prstGeom>
-          <a:noFill/>
-          <a:ln/>
-        </p:spPr>
-        <p:txBody>
-          <a:bodyPr wrap="square" rtlCol="0" anchor="ctr"/>
-          <a:lstStyle/>
-          <a:p>
-            <a:pPr indent="0" marL="0">
-              <a:buNone/>
-            </a:pPr>
-            <a:r>
-              <a:rPr lang="en-US" sz="1800" b="1" dirty="0">
+            <a:off x="1097280" y="1527048"/>
+            <a:ext cx="3108960" cy="768096"/>
+          </a:xfrm>
+          <a:prstGeom prst="rect">
+            <a:avLst/>
+          </a:prstGeom>
+          <a:noFill/>
+          <a:ln/>
+        </p:spPr>
+        <p:txBody>
+          <a:bodyPr wrap="square" rtlCol="0" anchor="ctr"/>
+          <a:lstStyle/>
+          <a:p>
+            <a:pPr indent="0" marL="0">
+              <a:buNone/>
+            </a:pPr>
+            <a:r>
+              <a:rPr lang="en-US" sz="1650" b="1" dirty="0">
                 <a:solidFill>
                   <a:srgbClr val="1F3864"/>
                 </a:solidFill>
@@ -2771,7 +2771,7 @@
               </a:rPr>
               <a:t>El clausulado completo</a:t>
             </a:r>
-            <a:endParaRPr lang="en-US" sz="1800" dirty="0"/>
+            <a:endParaRPr lang="en-US" sz="1650" dirty="0"/>
           </a:p>
         </p:txBody>
       </p:sp>
@@ -2783,24 +2783,24 @@
         </p:nvSpPr>
         <p:spPr>
           <a:xfrm>
-            <a:off x="4297680" y="1737360"/>
-            <a:ext cx="4937760" cy="960120"/>
-          </a:xfrm>
-          <a:prstGeom prst="rect">
-            <a:avLst/>
-          </a:prstGeom>
-          <a:noFill/>
-          <a:ln/>
-        </p:spPr>
-        <p:txBody>
-          <a:bodyPr wrap="square" rtlCol="0" anchor="ctr"/>
-          <a:lstStyle/>
-          <a:p>
-            <a:pPr indent="0" marL="0">
-              <a:buNone/>
-            </a:pPr>
-            <a:r>
-              <a:rPr lang="en-US" sz="1400" dirty="0">
+            <a:off x="4297680" y="1527048"/>
+            <a:ext cx="4937760" cy="768096"/>
+          </a:xfrm>
+          <a:prstGeom prst="rect">
+            <a:avLst/>
+          </a:prstGeom>
+          <a:noFill/>
+          <a:ln/>
+        </p:spPr>
+        <p:txBody>
+          <a:bodyPr wrap="square" rtlCol="0" anchor="ctr"/>
+          <a:lstStyle/>
+          <a:p>
+            <a:pPr indent="0" marL="0">
+              <a:buNone/>
+            </a:pPr>
+            <a:r>
+              <a:rPr lang="en-US" sz="1280" dirty="0">
                 <a:solidFill>
                   <a:srgbClr val="22201D"/>
                 </a:solidFill>
@@ -2810,7 +2810,7 @@
               </a:rPr>
               <a:t>Catálogo, memoria justificativa para la Intervención, circuito del expediente, caso piloto y anexos con todos los modelos.</a:t>
             </a:r>
-            <a:endParaRPr lang="en-US" sz="1400" dirty="0"/>
+            <a:endParaRPr lang="en-US" sz="1280" dirty="0"/>
           </a:p>
         </p:txBody>
       </p:sp>
@@ -2822,24 +2822,24 @@
         </p:nvSpPr>
         <p:spPr>
           <a:xfrm>
-            <a:off x="9326880" y="1737360"/>
-            <a:ext cx="1828800" cy="960120"/>
-          </a:xfrm>
-          <a:prstGeom prst="rect">
-            <a:avLst/>
-          </a:prstGeom>
-          <a:noFill/>
-          <a:ln/>
-        </p:spPr>
-        <p:txBody>
-          <a:bodyPr wrap="square" rtlCol="0" anchor="ctr"/>
-          <a:lstStyle/>
-          <a:p>
-            <a:pPr indent="0" marL="0">
-              <a:buNone/>
-            </a:pPr>
-            <a:r>
-              <a:rPr lang="en-US" sz="1250" i="1" dirty="0">
+            <a:off x="9326880" y="1527048"/>
+            <a:ext cx="1828800" cy="768096"/>
+          </a:xfrm>
+          <a:prstGeom prst="rect">
+            <a:avLst/>
+          </a:prstGeom>
+          <a:noFill/>
+          <a:ln/>
+        </p:spPr>
+        <p:txBody>
+          <a:bodyPr wrap="square" rtlCol="0" anchor="ctr"/>
+          <a:lstStyle/>
+          <a:p>
+            <a:pPr indent="0" marL="0">
+              <a:buNone/>
+            </a:pPr>
+            <a:r>
+              <a:rPr lang="en-US" sz="1120" i="1" dirty="0">
                 <a:solidFill>
                   <a:srgbClr val="6E6A63"/>
                 </a:solidFill>
@@ -2849,7 +2849,7 @@
               </a:rPr>
               <a:t>Quien redacta y quien fiscaliza</a:t>
             </a:r>
-            <a:endParaRPr lang="en-US" sz="1250" dirty="0"/>
+            <a:endParaRPr lang="en-US" sz="1120" dirty="0"/>
           </a:p>
         </p:txBody>
       </p:sp>
@@ -2861,12 +2861,12 @@
         </p:nvSpPr>
         <p:spPr>
           <a:xfrm>
-            <a:off x="822960" y="3017520"/>
-            <a:ext cx="10515600" cy="1234440"/>
+            <a:off x="822960" y="2560320"/>
+            <a:ext cx="10515600" cy="987552"/>
           </a:xfrm>
           <a:prstGeom prst="roundRect">
             <a:avLst>
-              <a:gd name="adj" fmla="val 7407"/>
+              <a:gd name="adj" fmla="val 9259"/>
             </a:avLst>
           </a:prstGeom>
           <a:solidFill>
@@ -2883,24 +2883,24 @@
         </p:nvSpPr>
         <p:spPr>
           <a:xfrm>
-            <a:off x="1097280" y="3154680"/>
-            <a:ext cx="3108960" cy="960120"/>
-          </a:xfrm>
-          <a:prstGeom prst="rect">
-            <a:avLst/>
-          </a:prstGeom>
-          <a:noFill/>
-          <a:ln/>
-        </p:spPr>
-        <p:txBody>
-          <a:bodyPr wrap="square" rtlCol="0" anchor="ctr"/>
-          <a:lstStyle/>
-          <a:p>
-            <a:pPr indent="0" marL="0">
-              <a:buNone/>
-            </a:pPr>
-            <a:r>
-              <a:rPr lang="en-US" sz="1800" b="1" dirty="0">
+            <a:off x="1097280" y="2670048"/>
+            <a:ext cx="3108960" cy="768096"/>
+          </a:xfrm>
+          <a:prstGeom prst="rect">
+            <a:avLst/>
+          </a:prstGeom>
+          <a:noFill/>
+          <a:ln/>
+        </p:spPr>
+        <p:txBody>
+          <a:bodyPr wrap="square" rtlCol="0" anchor="ctr"/>
+          <a:lstStyle/>
+          <a:p>
+            <a:pPr indent="0" marL="0">
+              <a:buNone/>
+            </a:pPr>
+            <a:r>
+              <a:rPr lang="en-US" sz="1650" b="1" dirty="0">
                 <a:solidFill>
                   <a:srgbClr val="1F3864"/>
                 </a:solidFill>
@@ -2908,9 +2908,9 @@
                 <a:ea typeface="Georgia" pitchFamily="34" charset="-122"/>
                 <a:cs typeface="Georgia" pitchFamily="34" charset="-120"/>
               </a:rPr>
-              <a:t>El resumen y la guía de uso</a:t>
-            </a:r>
-            <a:endParaRPr lang="en-US" sz="1800" dirty="0"/>
+              <a:t>La guía municipal · 20 páginas</a:t>
+            </a:r>
+            <a:endParaRPr lang="en-US" sz="1650" dirty="0"/>
           </a:p>
         </p:txBody>
       </p:sp>
@@ -2922,24 +2922,24 @@
         </p:nvSpPr>
         <p:spPr>
           <a:xfrm>
-            <a:off x="4297680" y="3154680"/>
-            <a:ext cx="4937760" cy="960120"/>
-          </a:xfrm>
-          <a:prstGeom prst="rect">
-            <a:avLst/>
-          </a:prstGeom>
-          <a:noFill/>
-          <a:ln/>
-        </p:spPr>
-        <p:txBody>
-          <a:bodyPr wrap="square" rtlCol="0" anchor="ctr"/>
-          <a:lstStyle/>
-          <a:p>
-            <a:pPr indent="0" marL="0">
-              <a:buNone/>
-            </a:pPr>
-            <a:r>
-              <a:rPr lang="en-US" sz="1400" dirty="0">
+            <a:off x="4297680" y="2670048"/>
+            <a:ext cx="4937760" cy="768096"/>
+          </a:xfrm>
+          <a:prstGeom prst="rect">
+            <a:avLst/>
+          </a:prstGeom>
+          <a:noFill/>
+          <a:ln/>
+        </p:spPr>
+        <p:txBody>
+          <a:bodyPr wrap="square" rtlCol="0" anchor="ctr"/>
+          <a:lstStyle/>
+          <a:p>
+            <a:pPr indent="0" marL="0">
+              <a:buNone/>
+            </a:pPr>
+            <a:r>
+              <a:rPr lang="en-US" sz="1280" dirty="0">
                 <a:solidFill>
                   <a:srgbClr val="22201D"/>
                 </a:solidFill>
@@ -2947,9 +2947,9 @@
                 <a:ea typeface="Calibri" pitchFamily="34" charset="-122"/>
                 <a:cs typeface="Calibri" pitchFamily="34" charset="-120"/>
               </a:rPr>
-              <a:t>La primera parte del documento, escrita para quien no sabe nada de contratación ni de tecnología.</a:t>
-            </a:r>
-            <a:endParaRPr lang="en-US" sz="1400" dirty="0"/>
+              <a:t>Cómo decidir, motivar, seleccionar, copiar y verificar sin recorrer el catálogo entero.</a:t>
+            </a:r>
+            <a:endParaRPr lang="en-US" sz="1280" dirty="0"/>
           </a:p>
         </p:txBody>
       </p:sp>
@@ -2961,24 +2961,24 @@
         </p:nvSpPr>
         <p:spPr>
           <a:xfrm>
-            <a:off x="9326880" y="3154680"/>
-            <a:ext cx="1828800" cy="960120"/>
-          </a:xfrm>
-          <a:prstGeom prst="rect">
-            <a:avLst/>
-          </a:prstGeom>
-          <a:noFill/>
-          <a:ln/>
-        </p:spPr>
-        <p:txBody>
-          <a:bodyPr wrap="square" rtlCol="0" anchor="ctr"/>
-          <a:lstStyle/>
-          <a:p>
-            <a:pPr indent="0" marL="0">
-              <a:buNone/>
-            </a:pPr>
-            <a:r>
-              <a:rPr lang="en-US" sz="1250" i="1" dirty="0">
+            <a:off x="9326880" y="2670048"/>
+            <a:ext cx="1828800" cy="768096"/>
+          </a:xfrm>
+          <a:prstGeom prst="rect">
+            <a:avLst/>
+          </a:prstGeom>
+          <a:noFill/>
+          <a:ln/>
+        </p:spPr>
+        <p:txBody>
+          <a:bodyPr wrap="square" rtlCol="0" anchor="ctr"/>
+          <a:lstStyle/>
+          <a:p>
+            <a:pPr indent="0" marL="0">
+              <a:buNone/>
+            </a:pPr>
+            <a:r>
+              <a:rPr lang="en-US" sz="1120" i="1" dirty="0">
                 <a:solidFill>
                   <a:srgbClr val="6E6A63"/>
                 </a:solidFill>
@@ -2986,9 +2986,9 @@
                 <a:ea typeface="Calibri" pitchFamily="34" charset="-122"/>
                 <a:cs typeface="Calibri" pitchFamily="34" charset="-120"/>
               </a:rPr>
-              <a:t>Alcaldía, concejalías, prensa</a:t>
-            </a:r>
-            <a:endParaRPr lang="en-US" sz="1250" dirty="0"/>
+              <a:t>Concejalía, Contratación, Intervención y TI</a:t>
+            </a:r>
+            <a:endParaRPr lang="en-US" sz="1120" dirty="0"/>
           </a:p>
         </p:txBody>
       </p:sp>
@@ -3000,12 +3000,12 @@
         </p:nvSpPr>
         <p:spPr>
           <a:xfrm>
-            <a:off x="822960" y="4434840"/>
-            <a:ext cx="10515600" cy="1234440"/>
+            <a:off x="822960" y="3703320"/>
+            <a:ext cx="10515600" cy="987552"/>
           </a:xfrm>
           <a:prstGeom prst="roundRect">
             <a:avLst>
-              <a:gd name="adj" fmla="val 7407"/>
+              <a:gd name="adj" fmla="val 9259"/>
             </a:avLst>
           </a:prstGeom>
           <a:solidFill>
@@ -3022,24 +3022,24 @@
         </p:nvSpPr>
         <p:spPr>
           <a:xfrm>
-            <a:off x="1097280" y="4572000"/>
-            <a:ext cx="3108960" cy="960120"/>
-          </a:xfrm>
-          <a:prstGeom prst="rect">
-            <a:avLst/>
-          </a:prstGeom>
-          <a:noFill/>
-          <a:ln/>
-        </p:spPr>
-        <p:txBody>
-          <a:bodyPr wrap="square" rtlCol="0" anchor="ctr"/>
-          <a:lstStyle/>
-          <a:p>
-            <a:pPr indent="0" marL="0">
-              <a:buNone/>
-            </a:pPr>
-            <a:r>
-              <a:rPr lang="en-US" sz="1800" b="1" dirty="0">
+            <a:off x="1097280" y="3813048"/>
+            <a:ext cx="3108960" cy="768096"/>
+          </a:xfrm>
+          <a:prstGeom prst="rect">
+            <a:avLst/>
+          </a:prstGeom>
+          <a:noFill/>
+          <a:ln/>
+        </p:spPr>
+        <p:txBody>
+          <a:bodyPr wrap="square" rtlCol="0" anchor="ctr"/>
+          <a:lstStyle/>
+          <a:p>
+            <a:pPr indent="0" marL="0">
+              <a:buNone/>
+            </a:pPr>
+            <a:r>
+              <a:rPr lang="en-US" sz="1650" b="1" dirty="0">
                 <a:solidFill>
                   <a:srgbClr val="1F3864"/>
                 </a:solidFill>
@@ -3047,9 +3047,9 @@
                 <a:ea typeface="Georgia" pitchFamily="34" charset="-122"/>
                 <a:cs typeface="Georgia" pitchFamily="34" charset="-120"/>
               </a:rPr>
-              <a:t>Esta presentación</a:t>
-            </a:r>
-            <a:endParaRPr lang="en-US" sz="1800" dirty="0"/>
+              <a:t>El resumen y la guía de uso</a:t>
+            </a:r>
+            <a:endParaRPr lang="en-US" sz="1650" dirty="0"/>
           </a:p>
         </p:txBody>
       </p:sp>
@@ -3061,24 +3061,24 @@
         </p:nvSpPr>
         <p:spPr>
           <a:xfrm>
-            <a:off x="4297680" y="4572000"/>
-            <a:ext cx="4937760" cy="960120"/>
-          </a:xfrm>
-          <a:prstGeom prst="rect">
-            <a:avLst/>
-          </a:prstGeom>
-          <a:noFill/>
-          <a:ln/>
-        </p:spPr>
-        <p:txBody>
-          <a:bodyPr wrap="square" rtlCol="0" anchor="ctr"/>
-          <a:lstStyle/>
-          <a:p>
-            <a:pPr indent="0" marL="0">
-              <a:buNone/>
-            </a:pPr>
-            <a:r>
-              <a:rPr lang="en-US" sz="1400" dirty="0">
+            <a:off x="4297680" y="3813048"/>
+            <a:ext cx="4937760" cy="768096"/>
+          </a:xfrm>
+          <a:prstGeom prst="rect">
+            <a:avLst/>
+          </a:prstGeom>
+          <a:noFill/>
+          <a:ln/>
+        </p:spPr>
+        <p:txBody>
+          <a:bodyPr wrap="square" rtlCol="0" anchor="ctr"/>
+          <a:lstStyle/>
+          <a:p>
+            <a:pPr indent="0" marL="0">
+              <a:buNone/>
+            </a:pPr>
+            <a:r>
+              <a:rPr lang="en-US" sz="1280" dirty="0">
                 <a:solidFill>
                   <a:srgbClr val="22201D"/>
                 </a:solidFill>
@@ -3086,9 +3086,9 @@
                 <a:ea typeface="Calibri" pitchFamily="34" charset="-122"/>
                 <a:cs typeface="Calibri" pitchFamily="34" charset="-120"/>
               </a:rPr>
-              <a:t>El problema y la solución, sin que haga falta saber nada previo.</a:t>
-            </a:r>
-            <a:endParaRPr lang="en-US" sz="1400" dirty="0"/>
+              <a:t>La primera parte del documento, escrita para quien no sabe nada de contratación ni de tecnología.</a:t>
+            </a:r>
+            <a:endParaRPr lang="en-US" sz="1280" dirty="0"/>
           </a:p>
         </p:txBody>
       </p:sp>
@@ -3100,24 +3100,24 @@
         </p:nvSpPr>
         <p:spPr>
           <a:xfrm>
-            <a:off x="9326880" y="4572000"/>
-            <a:ext cx="1828800" cy="960120"/>
-          </a:xfrm>
-          <a:prstGeom prst="rect">
-            <a:avLst/>
-          </a:prstGeom>
-          <a:noFill/>
-          <a:ln/>
-        </p:spPr>
-        <p:txBody>
-          <a:bodyPr wrap="square" rtlCol="0" anchor="ctr"/>
-          <a:lstStyle/>
-          <a:p>
-            <a:pPr indent="0" marL="0">
-              <a:buNone/>
-            </a:pPr>
-            <a:r>
-              <a:rPr lang="en-US" sz="1250" i="1" dirty="0">
+            <a:off x="9326880" y="3813048"/>
+            <a:ext cx="1828800" cy="768096"/>
+          </a:xfrm>
+          <a:prstGeom prst="rect">
+            <a:avLst/>
+          </a:prstGeom>
+          <a:noFill/>
+          <a:ln/>
+        </p:spPr>
+        <p:txBody>
+          <a:bodyPr wrap="square" rtlCol="0" anchor="ctr"/>
+          <a:lstStyle/>
+          <a:p>
+            <a:pPr indent="0" marL="0">
+              <a:buNone/>
+            </a:pPr>
+            <a:r>
+              <a:rPr lang="en-US" sz="1120" i="1" dirty="0">
                 <a:solidFill>
                   <a:srgbClr val="6E6A63"/>
                 </a:solidFill>
@@ -3125,38 +3125,99 @@
                 <a:ea typeface="Calibri" pitchFamily="34" charset="-122"/>
                 <a:cs typeface="Calibri" pitchFamily="34" charset="-120"/>
               </a:rPr>
-              <a:t>Cualquier sala</a:t>
-            </a:r>
-            <a:endParaRPr lang="en-US" sz="1250" dirty="0"/>
-          </a:p>
-        </p:txBody>
-      </p:sp>
-      <p:sp>
-        <p:nvSpPr>
-          <p:cNvPr id="15" name="Text 13"/>
-          <p:cNvSpPr/>
-          <p:nvPr/>
-        </p:nvSpPr>
-        <p:spPr>
-          <a:xfrm>
-            <a:off x="822960" y="5852160"/>
-            <a:ext cx="10515600" cy="640080"/>
-          </a:xfrm>
-          <a:prstGeom prst="rect">
-            <a:avLst/>
-          </a:prstGeom>
-          <a:noFill/>
-          <a:ln/>
-        </p:spPr>
-        <p:txBody>
-          <a:bodyPr wrap="square" rtlCol="0" anchor="ctr"/>
-          <a:lstStyle/>
-          <a:p>
-            <a:pPr indent="0" marL="0">
-              <a:buNone/>
-            </a:pPr>
-            <a:r>
-              <a:rPr lang="en-US" sz="1500" dirty="0">
+              <a:t>Alcaldía, concejalías, prensa</a:t>
+            </a:r>
+            <a:endParaRPr lang="en-US" sz="1120" dirty="0"/>
+          </a:p>
+        </p:txBody>
+      </p:sp>
+      <p:sp>
+        <p:nvSpPr>
+          <p:cNvPr id="15" name="Shape 13"/>
+          <p:cNvSpPr/>
+          <p:nvPr/>
+        </p:nvSpPr>
+        <p:spPr>
+          <a:xfrm>
+            <a:off x="822960" y="4846320"/>
+            <a:ext cx="10515600" cy="987552"/>
+          </a:xfrm>
+          <a:prstGeom prst="roundRect">
+            <a:avLst>
+              <a:gd name="adj" fmla="val 9259"/>
+            </a:avLst>
+          </a:prstGeom>
+          <a:solidFill>
+            <a:srgbClr val="EDF1F8"/>
+          </a:solidFill>
+          <a:ln/>
+        </p:spPr>
+      </p:sp>
+      <p:sp>
+        <p:nvSpPr>
+          <p:cNvPr id="16" name="Text 14"/>
+          <p:cNvSpPr/>
+          <p:nvPr/>
+        </p:nvSpPr>
+        <p:spPr>
+          <a:xfrm>
+            <a:off x="1097280" y="4956048"/>
+            <a:ext cx="3108960" cy="768096"/>
+          </a:xfrm>
+          <a:prstGeom prst="rect">
+            <a:avLst/>
+          </a:prstGeom>
+          <a:noFill/>
+          <a:ln/>
+        </p:spPr>
+        <p:txBody>
+          <a:bodyPr wrap="square" rtlCol="0" anchor="ctr"/>
+          <a:lstStyle/>
+          <a:p>
+            <a:pPr indent="0" marL="0">
+              <a:buNone/>
+            </a:pPr>
+            <a:r>
+              <a:rPr lang="en-US" sz="1650" b="1" dirty="0">
+                <a:solidFill>
+                  <a:srgbClr val="1F3864"/>
+                </a:solidFill>
+                <a:latin typeface="Georgia" pitchFamily="34" charset="0"/>
+                <a:ea typeface="Georgia" pitchFamily="34" charset="-122"/>
+                <a:cs typeface="Georgia" pitchFamily="34" charset="-120"/>
+              </a:rPr>
+              <a:t>Esta presentación</a:t>
+            </a:r>
+            <a:endParaRPr lang="en-US" sz="1650" dirty="0"/>
+          </a:p>
+        </p:txBody>
+      </p:sp>
+      <p:sp>
+        <p:nvSpPr>
+          <p:cNvPr id="17" name="Text 15"/>
+          <p:cNvSpPr/>
+          <p:nvPr/>
+        </p:nvSpPr>
+        <p:spPr>
+          <a:xfrm>
+            <a:off x="4297680" y="4956048"/>
+            <a:ext cx="4937760" cy="768096"/>
+          </a:xfrm>
+          <a:prstGeom prst="rect">
+            <a:avLst/>
+          </a:prstGeom>
+          <a:noFill/>
+          <a:ln/>
+        </p:spPr>
+        <p:txBody>
+          <a:bodyPr wrap="square" rtlCol="0" anchor="ctr"/>
+          <a:lstStyle/>
+          <a:p>
+            <a:pPr indent="0" marL="0">
+              <a:buNone/>
+            </a:pPr>
+            <a:r>
+              <a:rPr lang="en-US" sz="1280" dirty="0">
                 <a:solidFill>
                   <a:srgbClr val="22201D"/>
                 </a:solidFill>
@@ -3164,9 +3225,87 @@
                 <a:ea typeface="Calibri" pitchFamily="34" charset="-122"/>
                 <a:cs typeface="Calibri" pitchFamily="34" charset="-120"/>
               </a:rPr>
+              <a:t>El problema y la solución, sin que haga falta saber nada previo.</a:t>
+            </a:r>
+            <a:endParaRPr lang="en-US" sz="1280" dirty="0"/>
+          </a:p>
+        </p:txBody>
+      </p:sp>
+      <p:sp>
+        <p:nvSpPr>
+          <p:cNvPr id="18" name="Text 16"/>
+          <p:cNvSpPr/>
+          <p:nvPr/>
+        </p:nvSpPr>
+        <p:spPr>
+          <a:xfrm>
+            <a:off x="9326880" y="4956048"/>
+            <a:ext cx="1828800" cy="768096"/>
+          </a:xfrm>
+          <a:prstGeom prst="rect">
+            <a:avLst/>
+          </a:prstGeom>
+          <a:noFill/>
+          <a:ln/>
+        </p:spPr>
+        <p:txBody>
+          <a:bodyPr wrap="square" rtlCol="0" anchor="ctr"/>
+          <a:lstStyle/>
+          <a:p>
+            <a:pPr indent="0" marL="0">
+              <a:buNone/>
+            </a:pPr>
+            <a:r>
+              <a:rPr lang="en-US" sz="1120" i="1" dirty="0">
+                <a:solidFill>
+                  <a:srgbClr val="6E6A63"/>
+                </a:solidFill>
+                <a:latin typeface="Calibri" pitchFamily="34" charset="0"/>
+                <a:ea typeface="Calibri" pitchFamily="34" charset="-122"/>
+                <a:cs typeface="Calibri" pitchFamily="34" charset="-120"/>
+              </a:rPr>
+              <a:t>Cualquier sala</a:t>
+            </a:r>
+            <a:endParaRPr lang="en-US" sz="1120" dirty="0"/>
+          </a:p>
+        </p:txBody>
+      </p:sp>
+      <p:sp>
+        <p:nvSpPr>
+          <p:cNvPr id="19" name="Text 17"/>
+          <p:cNvSpPr/>
+          <p:nvPr/>
+        </p:nvSpPr>
+        <p:spPr>
+          <a:xfrm>
+            <a:off x="822960" y="6080760"/>
+            <a:ext cx="10515600" cy="411480"/>
+          </a:xfrm>
+          <a:prstGeom prst="rect">
+            <a:avLst/>
+          </a:prstGeom>
+          <a:noFill/>
+          <a:ln/>
+        </p:spPr>
+        <p:txBody>
+          <a:bodyPr wrap="square" rtlCol="0" anchor="ctr"/>
+          <a:lstStyle/>
+          <a:p>
+            <a:pPr indent="0" marL="0">
+              <a:buNone/>
+            </a:pPr>
+            <a:r>
+              <a:rPr lang="en-US" sz="1350" dirty="0">
+                <a:solidFill>
+                  <a:srgbClr val="22201D"/>
+                </a:solidFill>
+                <a:latin typeface="Calibri" pitchFamily="34" charset="0"/>
+                <a:ea typeface="Calibri" pitchFamily="34" charset="-122"/>
+                <a:cs typeface="Calibri" pitchFamily="34" charset="-120"/>
+              </a:rPr>
               <a:t>Todo en abierto, bajo licencia Creative Commons Attribution 4.0: se puede copiar, adaptar y usar con cualquier finalidad, citando la autoría.</a:t>
             </a:r>
-            <a:endParaRPr lang="en-US" sz="1500" dirty="0"/>
+            <a:endParaRPr lang="en-US" sz="1350" dirty="0"/>
           </a:p>
         </p:txBody>
       </p:sp>
@@ -3274,7 +3413,7 @@
                 <a:ea typeface="Calibri" pitchFamily="34" charset="-122"/>
                 <a:cs typeface="Calibri" pitchFamily="34" charset="-120"/>
               </a:rPr>
-              <a:t>Un trabajo conjunto de varios meses entre tres personas, cada una desde su oficio, con el Ayuntamiento de Pozuelo de Alarcón como banco de pruebas real.</a:t>
+              <a:t>Un trabajo conjunto de varios meses entre cinco personas, cada una desde su oficio, con el Ayuntamiento de Pozuelo de Alarcón como banco de pruebas real.</a:t>
             </a:r>
             <a:endParaRPr lang="en-US" sz="1600" dirty="0"/>
           </a:p>
@@ -3288,8 +3427,8 @@
         </p:nvSpPr>
         <p:spPr>
           <a:xfrm>
-            <a:off x="822960" y="2057400"/>
-            <a:ext cx="82296" cy="1170432"/>
+            <a:off x="822960" y="1965960"/>
+            <a:ext cx="82296" cy="822960"/>
           </a:xfrm>
           <a:prstGeom prst="rect">
             <a:avLst/>
@@ -3308,24 +3447,24 @@
         </p:nvSpPr>
         <p:spPr>
           <a:xfrm>
-            <a:off x="1188720" y="2057400"/>
-            <a:ext cx="10058400" cy="365760"/>
-          </a:xfrm>
-          <a:prstGeom prst="rect">
-            <a:avLst/>
-          </a:prstGeom>
-          <a:noFill/>
-          <a:ln/>
-        </p:spPr>
-        <p:txBody>
-          <a:bodyPr wrap="square" rtlCol="0" anchor="ctr"/>
-          <a:lstStyle/>
-          <a:p>
-            <a:pPr indent="0" marL="0">
-              <a:buNone/>
-            </a:pPr>
-            <a:r>
-              <a:rPr lang="en-US" sz="1800" b="1" dirty="0">
+            <a:off x="1188720" y="1965960"/>
+            <a:ext cx="10058400" cy="246888"/>
+          </a:xfrm>
+          <a:prstGeom prst="rect">
+            <a:avLst/>
+          </a:prstGeom>
+          <a:noFill/>
+          <a:ln/>
+        </p:spPr>
+        <p:txBody>
+          <a:bodyPr wrap="square" rtlCol="0" anchor="ctr"/>
+          <a:lstStyle/>
+          <a:p>
+            <a:pPr indent="0" marL="0">
+              <a:buNone/>
+            </a:pPr>
+            <a:r>
+              <a:rPr lang="en-US" sz="1550" b="1" dirty="0">
                 <a:solidFill>
                   <a:srgbClr val="1F3864"/>
                 </a:solidFill>
@@ -3335,7 +3474,7 @@
               </a:rPr>
               <a:t>Delfina Lafuente Veira</a:t>
             </a:r>
-            <a:endParaRPr lang="en-US" sz="1800" dirty="0"/>
+            <a:endParaRPr lang="en-US" sz="1550" dirty="0"/>
           </a:p>
         </p:txBody>
       </p:sp>
@@ -3347,24 +3486,24 @@
         </p:nvSpPr>
         <p:spPr>
           <a:xfrm>
-            <a:off x="1188720" y="2423160"/>
-            <a:ext cx="10058400" cy="292608"/>
-          </a:xfrm>
-          <a:prstGeom prst="rect">
-            <a:avLst/>
-          </a:prstGeom>
-          <a:noFill/>
-          <a:ln/>
-        </p:spPr>
-        <p:txBody>
-          <a:bodyPr wrap="square" rtlCol="0" anchor="ctr"/>
-          <a:lstStyle/>
-          <a:p>
-            <a:pPr indent="0" marL="0">
-              <a:buNone/>
-            </a:pPr>
-            <a:r>
-              <a:rPr lang="en-US" sz="1300" dirty="0">
+            <a:off x="1188720" y="2212848"/>
+            <a:ext cx="10058400" cy="210312"/>
+          </a:xfrm>
+          <a:prstGeom prst="rect">
+            <a:avLst/>
+          </a:prstGeom>
+          <a:noFill/>
+          <a:ln/>
+        </p:spPr>
+        <p:txBody>
+          <a:bodyPr wrap="square" rtlCol="0" anchor="ctr"/>
+          <a:lstStyle/>
+          <a:p>
+            <a:pPr indent="0" marL="0">
+              <a:buNone/>
+            </a:pPr>
+            <a:r>
+              <a:rPr lang="en-US" sz="1080" dirty="0">
                 <a:solidFill>
                   <a:srgbClr val="6E6A63"/>
                 </a:solidFill>
@@ -3374,7 +3513,7 @@
               </a:rPr>
               <a:t>Concejal de Administración Digital, Calidad e Innovación · Ayuntamiento de Pozuelo de Alarcón  ·  pozuelodealarcon.org</a:t>
             </a:r>
-            <a:endParaRPr lang="en-US" sz="1300" dirty="0"/>
+            <a:endParaRPr lang="en-US" sz="1080" dirty="0"/>
           </a:p>
         </p:txBody>
       </p:sp>
@@ -3386,24 +3525,24 @@
         </p:nvSpPr>
         <p:spPr>
           <a:xfrm>
-            <a:off x="1188720" y="2734056"/>
-            <a:ext cx="10058400" cy="502920"/>
-          </a:xfrm>
-          <a:prstGeom prst="rect">
-            <a:avLst/>
-          </a:prstGeom>
-          <a:noFill/>
-          <a:ln/>
-        </p:spPr>
-        <p:txBody>
-          <a:bodyPr wrap="square" rtlCol="0" anchor="ctr"/>
-          <a:lstStyle/>
-          <a:p>
-            <a:pPr indent="0" marL="0">
-              <a:buNone/>
-            </a:pPr>
-            <a:r>
-              <a:rPr lang="en-US" sz="1350" dirty="0">
+            <a:off x="1188720" y="2423160"/>
+            <a:ext cx="10058400" cy="365760"/>
+          </a:xfrm>
+          <a:prstGeom prst="rect">
+            <a:avLst/>
+          </a:prstGeom>
+          <a:noFill/>
+          <a:ln/>
+        </p:spPr>
+        <p:txBody>
+          <a:bodyPr wrap="square" rtlCol="0" anchor="ctr"/>
+          <a:lstStyle/>
+          <a:p>
+            <a:pPr indent="0" marL="0">
+              <a:buNone/>
+            </a:pPr>
+            <a:r>
+              <a:rPr lang="en-US" sz="1140" dirty="0">
                 <a:solidFill>
                   <a:srgbClr val="22201D"/>
                 </a:solidFill>
@@ -3413,7 +3552,7 @@
               </a:rPr>
               <a:t>De ella nace el proyecto y suya es la primera redacción. Y suyo es el mérito menos visible: llevarlo a los servicios de contratación y jurídicos de su propio ayuntamiento y traer sus objeciones de vuelta enteras.</a:t>
             </a:r>
-            <a:endParaRPr lang="en-US" sz="1350" dirty="0"/>
+            <a:endParaRPr lang="en-US" sz="1140" dirty="0"/>
           </a:p>
         </p:txBody>
       </p:sp>
@@ -3425,8 +3564,8 @@
         </p:nvSpPr>
         <p:spPr>
           <a:xfrm>
-            <a:off x="822960" y="3429000"/>
-            <a:ext cx="82296" cy="1170432"/>
+            <a:off x="822960" y="2935224"/>
+            <a:ext cx="82296" cy="822960"/>
           </a:xfrm>
           <a:prstGeom prst="rect">
             <a:avLst/>
@@ -3445,24 +3584,24 @@
         </p:nvSpPr>
         <p:spPr>
           <a:xfrm>
-            <a:off x="1188720" y="3429000"/>
-            <a:ext cx="10058400" cy="365760"/>
-          </a:xfrm>
-          <a:prstGeom prst="rect">
-            <a:avLst/>
-          </a:prstGeom>
-          <a:noFill/>
-          <a:ln/>
-        </p:spPr>
-        <p:txBody>
-          <a:bodyPr wrap="square" rtlCol="0" anchor="ctr"/>
-          <a:lstStyle/>
-          <a:p>
-            <a:pPr indent="0" marL="0">
-              <a:buNone/>
-            </a:pPr>
-            <a:r>
-              <a:rPr lang="en-US" sz="1800" b="1" dirty="0">
+            <a:off x="1188720" y="2935224"/>
+            <a:ext cx="10058400" cy="246888"/>
+          </a:xfrm>
+          <a:prstGeom prst="rect">
+            <a:avLst/>
+          </a:prstGeom>
+          <a:noFill/>
+          <a:ln/>
+        </p:spPr>
+        <p:txBody>
+          <a:bodyPr wrap="square" rtlCol="0" anchor="ctr"/>
+          <a:lstStyle/>
+          <a:p>
+            <a:pPr indent="0" marL="0">
+              <a:buNone/>
+            </a:pPr>
+            <a:r>
+              <a:rPr lang="en-US" sz="1550" b="1" dirty="0">
                 <a:solidFill>
                   <a:srgbClr val="1F3864"/>
                 </a:solidFill>
@@ -3472,7 +3611,7 @@
               </a:rPr>
               <a:t>Dr. José Antonio Ondiviela García</a:t>
             </a:r>
-            <a:endParaRPr lang="en-US" sz="1800" dirty="0"/>
+            <a:endParaRPr lang="en-US" sz="1550" dirty="0"/>
           </a:p>
         </p:txBody>
       </p:sp>
@@ -3484,24 +3623,24 @@
         </p:nvSpPr>
         <p:spPr>
           <a:xfrm>
-            <a:off x="1188720" y="3794760"/>
-            <a:ext cx="10058400" cy="292608"/>
-          </a:xfrm>
-          <a:prstGeom prst="rect">
-            <a:avLst/>
-          </a:prstGeom>
-          <a:noFill/>
-          <a:ln/>
-        </p:spPr>
-        <p:txBody>
-          <a:bodyPr wrap="square" rtlCol="0" anchor="ctr"/>
-          <a:lstStyle/>
-          <a:p>
-            <a:pPr indent="0" marL="0">
-              <a:buNone/>
-            </a:pPr>
-            <a:r>
-              <a:rPr lang="en-US" sz="1300" dirty="0">
+            <a:off x="1188720" y="3182112"/>
+            <a:ext cx="10058400" cy="210312"/>
+          </a:xfrm>
+          <a:prstGeom prst="rect">
+            <a:avLst/>
+          </a:prstGeom>
+          <a:noFill/>
+          <a:ln/>
+        </p:spPr>
+        <p:txBody>
+          <a:bodyPr wrap="square" rtlCol="0" anchor="ctr"/>
+          <a:lstStyle/>
+          <a:p>
+            <a:pPr indent="0" marL="0">
+              <a:buNone/>
+            </a:pPr>
+            <a:r>
+              <a:rPr lang="en-US" sz="1080" dirty="0">
                 <a:solidFill>
                   <a:srgbClr val="6E6A63"/>
                 </a:solidFill>
@@ -3511,7 +3650,7 @@
               </a:rPr>
               <a:t>Profesor e investigador de la Escuela Politécnica Superior · Universidad Francisco de Vitoria  ·  ufv.es</a:t>
             </a:r>
-            <a:endParaRPr lang="en-US" sz="1300" dirty="0"/>
+            <a:endParaRPr lang="en-US" sz="1080" dirty="0"/>
           </a:p>
         </p:txBody>
       </p:sp>
@@ -3523,24 +3662,24 @@
         </p:nvSpPr>
         <p:spPr>
           <a:xfrm>
-            <a:off x="1188720" y="4105656"/>
-            <a:ext cx="10058400" cy="502920"/>
-          </a:xfrm>
-          <a:prstGeom prst="rect">
-            <a:avLst/>
-          </a:prstGeom>
-          <a:noFill/>
-          <a:ln/>
-        </p:spPr>
-        <p:txBody>
-          <a:bodyPr wrap="square" rtlCol="0" anchor="ctr"/>
-          <a:lstStyle/>
-          <a:p>
-            <a:pPr indent="0" marL="0">
-              <a:buNone/>
-            </a:pPr>
-            <a:r>
-              <a:rPr lang="en-US" sz="1350" dirty="0">
+            <a:off x="1188720" y="3392424"/>
+            <a:ext cx="10058400" cy="365760"/>
+          </a:xfrm>
+          <a:prstGeom prst="rect">
+            <a:avLst/>
+          </a:prstGeom>
+          <a:noFill/>
+          <a:ln/>
+        </p:spPr>
+        <p:txBody>
+          <a:bodyPr wrap="square" rtlCol="0" anchor="ctr"/>
+          <a:lstStyle/>
+          <a:p>
+            <a:pPr indent="0" marL="0">
+              <a:buNone/>
+            </a:pPr>
+            <a:r>
+              <a:rPr lang="en-US" sz="1140" dirty="0">
                 <a:solidFill>
                   <a:srgbClr val="22201D"/>
                 </a:solidFill>
@@ -3550,7 +3689,7 @@
               </a:rPr>
               <a:t>La mirada del mercado: qué se le puede pedir de verdad a un fabricante de software y qué hará que no se presente. Suya es la idea que resuelve el problema de fondo.</a:t>
             </a:r>
-            <a:endParaRPr lang="en-US" sz="1350" dirty="0"/>
+            <a:endParaRPr lang="en-US" sz="1140" dirty="0"/>
           </a:p>
         </p:txBody>
       </p:sp>
@@ -3562,8 +3701,8 @@
         </p:nvSpPr>
         <p:spPr>
           <a:xfrm>
-            <a:off x="822960" y="4800600"/>
-            <a:ext cx="82296" cy="1170432"/>
+            <a:off x="822960" y="3904488"/>
+            <a:ext cx="82296" cy="822960"/>
           </a:xfrm>
           <a:prstGeom prst="rect">
             <a:avLst/>
@@ -3582,24 +3721,24 @@
         </p:nvSpPr>
         <p:spPr>
           <a:xfrm>
-            <a:off x="1188720" y="4800600"/>
-            <a:ext cx="10058400" cy="365760"/>
-          </a:xfrm>
-          <a:prstGeom prst="rect">
-            <a:avLst/>
-          </a:prstGeom>
-          <a:noFill/>
-          <a:ln/>
-        </p:spPr>
-        <p:txBody>
-          <a:bodyPr wrap="square" rtlCol="0" anchor="ctr"/>
-          <a:lstStyle/>
-          <a:p>
-            <a:pPr indent="0" marL="0">
-              <a:buNone/>
-            </a:pPr>
-            <a:r>
-              <a:rPr lang="en-US" sz="1800" b="1" dirty="0">
+            <a:off x="1188720" y="3904488"/>
+            <a:ext cx="10058400" cy="246888"/>
+          </a:xfrm>
+          <a:prstGeom prst="rect">
+            <a:avLst/>
+          </a:prstGeom>
+          <a:noFill/>
+          <a:ln/>
+        </p:spPr>
+        <p:txBody>
+          <a:bodyPr wrap="square" rtlCol="0" anchor="ctr"/>
+          <a:lstStyle/>
+          <a:p>
+            <a:pPr indent="0" marL="0">
+              <a:buNone/>
+            </a:pPr>
+            <a:r>
+              <a:rPr lang="en-US" sz="1550" b="1" dirty="0">
                 <a:solidFill>
                   <a:srgbClr val="1F3864"/>
                 </a:solidFill>
@@ -3609,7 +3748,7 @@
               </a:rPr>
               <a:t>Miguel Ángel Domínguez Castellano</a:t>
             </a:r>
-            <a:endParaRPr lang="en-US" sz="1800" dirty="0"/>
+            <a:endParaRPr lang="en-US" sz="1550" dirty="0"/>
           </a:p>
         </p:txBody>
       </p:sp>
@@ -3621,24 +3760,24 @@
         </p:nvSpPr>
         <p:spPr>
           <a:xfrm>
-            <a:off x="1188720" y="5166360"/>
-            <a:ext cx="10058400" cy="292608"/>
-          </a:xfrm>
-          <a:prstGeom prst="rect">
-            <a:avLst/>
-          </a:prstGeom>
-          <a:noFill/>
-          <a:ln/>
-        </p:spPr>
-        <p:txBody>
-          <a:bodyPr wrap="square" rtlCol="0" anchor="ctr"/>
-          <a:lstStyle/>
-          <a:p>
-            <a:pPr indent="0" marL="0">
-              <a:buNone/>
-            </a:pPr>
-            <a:r>
-              <a:rPr lang="en-US" sz="1300" dirty="0">
+            <a:off x="1188720" y="4151376"/>
+            <a:ext cx="10058400" cy="210312"/>
+          </a:xfrm>
+          <a:prstGeom prst="rect">
+            <a:avLst/>
+          </a:prstGeom>
+          <a:noFill/>
+          <a:ln/>
+        </p:spPr>
+        <p:txBody>
+          <a:bodyPr wrap="square" rtlCol="0" anchor="ctr"/>
+          <a:lstStyle/>
+          <a:p>
+            <a:pPr indent="0" marL="0">
+              <a:buNone/>
+            </a:pPr>
+            <a:r>
+              <a:rPr lang="en-US" sz="1080" dirty="0">
                 <a:solidFill>
                   <a:srgbClr val="6E6A63"/>
                 </a:solidFill>
@@ -3648,7 +3787,7 @@
               </a:rPr>
               <a:t>CEO de Add4u · Presidente de Alastria · Presidente del Clúster de Blockchain de la Comunidad de Madrid  ·  miguelangeldominguez.info</a:t>
             </a:r>
-            <a:endParaRPr lang="en-US" sz="1300" dirty="0"/>
+            <a:endParaRPr lang="en-US" sz="1080" dirty="0"/>
           </a:p>
         </p:txBody>
       </p:sp>
@@ -3660,24 +3799,24 @@
         </p:nvSpPr>
         <p:spPr>
           <a:xfrm>
-            <a:off x="1188720" y="5477256"/>
-            <a:ext cx="10058400" cy="502920"/>
-          </a:xfrm>
-          <a:prstGeom prst="rect">
-            <a:avLst/>
-          </a:prstGeom>
-          <a:noFill/>
-          <a:ln/>
-        </p:spPr>
-        <p:txBody>
-          <a:bodyPr wrap="square" rtlCol="0" anchor="ctr"/>
-          <a:lstStyle/>
-          <a:p>
-            <a:pPr indent="0" marL="0">
-              <a:buNone/>
-            </a:pPr>
-            <a:r>
-              <a:rPr lang="en-US" sz="1350" dirty="0">
+            <a:off x="1188720" y="4361688"/>
+            <a:ext cx="10058400" cy="365760"/>
+          </a:xfrm>
+          <a:prstGeom prst="rect">
+            <a:avLst/>
+          </a:prstGeom>
+          <a:noFill/>
+          <a:ln/>
+        </p:spPr>
+        <p:txBody>
+          <a:bodyPr wrap="square" rtlCol="0" anchor="ctr"/>
+          <a:lstStyle/>
+          <a:p>
+            <a:pPr indent="0" marL="0">
+              <a:buNone/>
+            </a:pPr>
+            <a:r>
+              <a:rPr lang="en-US" sz="1140" dirty="0">
                 <a:solidFill>
                   <a:srgbClr val="22201D"/>
                 </a:solidFill>
@@ -3687,36 +3826,95 @@
               </a:rPr>
               <a:t>La perspectiva de quien conoce las dos orillas: la de quien redacta pliegos y la de quien se presenta a ellos. Asume la responsabilidad editorial de la publicación.</a:t>
             </a:r>
-            <a:endParaRPr lang="en-US" sz="1350" dirty="0"/>
-          </a:p>
-        </p:txBody>
-      </p:sp>
-      <p:sp>
-        <p:nvSpPr>
-          <p:cNvPr id="16" name="Text 14"/>
-          <p:cNvSpPr/>
-          <p:nvPr/>
-        </p:nvSpPr>
-        <p:spPr>
-          <a:xfrm>
-            <a:off x="822960" y="5806440"/>
-            <a:ext cx="10515600" cy="731520"/>
-          </a:xfrm>
-          <a:prstGeom prst="rect">
-            <a:avLst/>
-          </a:prstGeom>
-          <a:noFill/>
-          <a:ln/>
-        </p:spPr>
-        <p:txBody>
-          <a:bodyPr wrap="square" rtlCol="0" anchor="ctr"/>
-          <a:lstStyle/>
-          <a:p>
-            <a:pPr indent="0" marL="0">
-              <a:buNone/>
-            </a:pPr>
-            <a:r>
-              <a:rPr lang="en-US" sz="1350" i="1" dirty="0">
+            <a:endParaRPr lang="en-US" sz="1140" dirty="0"/>
+          </a:p>
+        </p:txBody>
+      </p:sp>
+      <p:sp>
+        <p:nvSpPr>
+          <p:cNvPr id="16" name="Shape 14"/>
+          <p:cNvSpPr/>
+          <p:nvPr/>
+        </p:nvSpPr>
+        <p:spPr>
+          <a:xfrm>
+            <a:off x="822960" y="4873752"/>
+            <a:ext cx="82296" cy="822960"/>
+          </a:xfrm>
+          <a:prstGeom prst="rect">
+            <a:avLst/>
+          </a:prstGeom>
+          <a:solidFill>
+            <a:srgbClr val="1F3864"/>
+          </a:solidFill>
+          <a:ln/>
+        </p:spPr>
+      </p:sp>
+      <p:sp>
+        <p:nvSpPr>
+          <p:cNvPr id="17" name="Text 15"/>
+          <p:cNvSpPr/>
+          <p:nvPr/>
+        </p:nvSpPr>
+        <p:spPr>
+          <a:xfrm>
+            <a:off x="1188720" y="4873752"/>
+            <a:ext cx="10058400" cy="246888"/>
+          </a:xfrm>
+          <a:prstGeom prst="rect">
+            <a:avLst/>
+          </a:prstGeom>
+          <a:noFill/>
+          <a:ln/>
+        </p:spPr>
+        <p:txBody>
+          <a:bodyPr wrap="square" rtlCol="0" anchor="ctr"/>
+          <a:lstStyle/>
+          <a:p>
+            <a:pPr indent="0" marL="0">
+              <a:buNone/>
+            </a:pPr>
+            <a:r>
+              <a:rPr lang="en-US" sz="1550" b="1" dirty="0">
+                <a:solidFill>
+                  <a:srgbClr val="1F3864"/>
+                </a:solidFill>
+                <a:latin typeface="Georgia" pitchFamily="34" charset="0"/>
+                <a:ea typeface="Georgia" pitchFamily="34" charset="-122"/>
+                <a:cs typeface="Georgia" pitchFamily="34" charset="-120"/>
+              </a:rPr>
+              <a:t>Enrique Jiménez y Roberto García</a:t>
+            </a:r>
+            <a:endParaRPr lang="en-US" sz="1550" dirty="0"/>
+          </a:p>
+        </p:txBody>
+      </p:sp>
+      <p:sp>
+        <p:nvSpPr>
+          <p:cNvPr id="18" name="Text 16"/>
+          <p:cNvSpPr/>
+          <p:nvPr/>
+        </p:nvSpPr>
+        <p:spPr>
+          <a:xfrm>
+            <a:off x="1188720" y="5120640"/>
+            <a:ext cx="10058400" cy="210312"/>
+          </a:xfrm>
+          <a:prstGeom prst="rect">
+            <a:avLst/>
+          </a:prstGeom>
+          <a:noFill/>
+          <a:ln/>
+        </p:spPr>
+        <p:txBody>
+          <a:bodyPr wrap="square" rtlCol="0" anchor="ctr"/>
+          <a:lstStyle/>
+          <a:p>
+            <a:pPr indent="0" marL="0">
+              <a:buNone/>
+            </a:pPr>
+            <a:r>
+              <a:rPr lang="en-US" sz="1080" dirty="0">
                 <a:solidFill>
                   <a:srgbClr val="6E6A63"/>
                 </a:solidFill>
@@ -3724,9 +3922,87 @@
                 <a:ea typeface="Calibri" pitchFamily="34" charset="-122"/>
                 <a:cs typeface="Calibri" pitchFamily="34" charset="-120"/>
               </a:rPr>
-              <a:t>El área de contratación del Ayuntamiento de Pozuelo de Alarcón no figura como autora y sin embargo ha determinado la forma del documento más que ninguna otra aportación: sus tres objeciones son la razón de ser de esta versión.</a:t>
-            </a:r>
-            <a:endParaRPr lang="en-US" sz="1350" dirty="0"/>
+              <a:t>Técnicos del área de contratación · Ayuntamiento de Pozuelo de Alarcón</a:t>
+            </a:r>
+            <a:endParaRPr lang="en-US" sz="1080" dirty="0"/>
+          </a:p>
+        </p:txBody>
+      </p:sp>
+      <p:sp>
+        <p:nvSpPr>
+          <p:cNvPr id="19" name="Text 17"/>
+          <p:cNvSpPr/>
+          <p:nvPr/>
+        </p:nvSpPr>
+        <p:spPr>
+          <a:xfrm>
+            <a:off x="1188720" y="5330952"/>
+            <a:ext cx="10058400" cy="365760"/>
+          </a:xfrm>
+          <a:prstGeom prst="rect">
+            <a:avLst/>
+          </a:prstGeom>
+          <a:noFill/>
+          <a:ln/>
+        </p:spPr>
+        <p:txBody>
+          <a:bodyPr wrap="square" rtlCol="0" anchor="ctr"/>
+          <a:lstStyle/>
+          <a:p>
+            <a:pPr indent="0" marL="0">
+              <a:buNone/>
+            </a:pPr>
+            <a:r>
+              <a:rPr lang="en-US" sz="1140" dirty="0">
+                <a:solidFill>
+                  <a:srgbClr val="22201D"/>
+                </a:solidFill>
+                <a:latin typeface="Calibri" pitchFamily="34" charset="0"/>
+                <a:ea typeface="Calibri" pitchFamily="34" charset="-122"/>
+                <a:cs typeface="Calibri" pitchFamily="34" charset="-120"/>
+              </a:rPr>
+              <a:t>Autores y supervisores técnicos: han aportado el contraste de la práctica municipal y la supervisión técnica de la formulación contractual.</a:t>
+            </a:r>
+            <a:endParaRPr lang="en-US" sz="1140" dirty="0"/>
+          </a:p>
+        </p:txBody>
+      </p:sp>
+      <p:sp>
+        <p:nvSpPr>
+          <p:cNvPr id="20" name="Text 18"/>
+          <p:cNvSpPr/>
+          <p:nvPr/>
+        </p:nvSpPr>
+        <p:spPr>
+          <a:xfrm>
+            <a:off x="822960" y="5989320"/>
+            <a:ext cx="10515600" cy="411480"/>
+          </a:xfrm>
+          <a:prstGeom prst="rect">
+            <a:avLst/>
+          </a:prstGeom>
+          <a:noFill/>
+          <a:ln/>
+        </p:spPr>
+        <p:txBody>
+          <a:bodyPr wrap="square" rtlCol="0" anchor="ctr"/>
+          <a:lstStyle/>
+          <a:p>
+            <a:pPr indent="0" marL="0">
+              <a:buNone/>
+            </a:pPr>
+            <a:r>
+              <a:rPr lang="en-US" sz="1180" i="1" dirty="0">
+                <a:solidFill>
+                  <a:srgbClr val="6E6A63"/>
+                </a:solidFill>
+                <a:latin typeface="Calibri" pitchFamily="34" charset="0"/>
+                <a:ea typeface="Calibri" pitchFamily="34" charset="-122"/>
+                <a:cs typeface="Calibri" pitchFamily="34" charset="-120"/>
+              </a:rPr>
+              <a:t>Las tres objeciones formuladas desde el área de contratación son la razón de ser de esta versión y están respondidas en el cuerpo del documento.</a:t>
+            </a:r>
+            <a:endParaRPr lang="en-US" sz="1180" dirty="0"/>
           </a:p>
         </p:txBody>
       </p:sp>

</xml_diff>

<commit_message>
El PowerPoint salía de otra fuente y se quedó con el texto viejo
`build_pptx.js` no usa `presentacion.js`: tiene su propia copia del texto de
las diapositivas. Al corregir la atribución sólo cambió `presentacion.js`, de
modo que el PDF del deck quedó bien y el .pptx siguió diciendo «área de
contratación» tres veces y «Técnicos del área de contratación» una.

Se sincroniza el .pptx con el resto: cuatro objeciones en vez de tres, cargos
correctos de Enrique y Roberto, y el ejemplo trabajado en vez del «caso
piloto». La diapositiva 9 pasa de tres tarjetas a cuatro, con la geometría
reajustada para que la última acabe en 6,43 y no pise el pie de 6,55.

Comprobado abriendo ppt/slides/*.xml del .pptx, no su PDF: era justamente el
error que dejó pasar el fallo.

Co-Authored-By: Claude Opus 5 <noreply@anthropic.com>
</commit_message>
<xml_diff>
--- a/docs/descargas/presentacion-ai-clauses.pptx
+++ b/docs/descargas/presentacion-ai-clauses.pptx
@@ -2468,7 +2468,7 @@
                 <a:ea typeface="Calibri" pitchFamily="34" charset="-122"/>
                 <a:cs typeface="Calibri" pitchFamily="34" charset="-120"/>
               </a:rPr>
-              <a:t>Un caso piloto resuelto de principio a fin.</a:t>
+              <a:t>Un ejemplo completo trabajado, de principio a fin, sobre un expediente simulado.</a:t>
             </a:r>
             <a:endParaRPr lang="en-US" sz="1600" dirty="0"/>
           </a:p>
@@ -2808,7 +2808,7 @@
                 <a:ea typeface="Calibri" pitchFamily="34" charset="-122"/>
                 <a:cs typeface="Calibri" pitchFamily="34" charset="-120"/>
               </a:rPr>
-              <a:t>Catálogo, memoria justificativa para la Intervención, circuito del expediente, caso piloto y anexos con todos los modelos.</a:t>
+              <a:t>Catálogo, memoria justificativa para los órganos de control, circuito del expediente, ejemplo trabajado y anexos con todos los modelos.</a:t>
             </a:r>
             <a:endParaRPr lang="en-US" sz="1280" dirty="0"/>
           </a:p>
@@ -3922,7 +3922,7 @@
                 <a:ea typeface="Calibri" pitchFamily="34" charset="-122"/>
                 <a:cs typeface="Calibri" pitchFamily="34" charset="-120"/>
               </a:rPr>
-              <a:t>Técnicos del área de contratación · Ayuntamiento de Pozuelo de Alarcón</a:t>
+              <a:t>Responsable de los contratos de innovación · Jefe de informática — Ayuntamiento de Pozuelo de Alarcón</a:t>
             </a:r>
             <a:endParaRPr lang="en-US" sz="1080" dirty="0"/>
           </a:p>
@@ -3975,24 +3975,24 @@
         </p:nvSpPr>
         <p:spPr>
           <a:xfrm>
-            <a:off x="822960" y="5989320"/>
-            <a:ext cx="10515600" cy="411480"/>
-          </a:xfrm>
-          <a:prstGeom prst="rect">
-            <a:avLst/>
-          </a:prstGeom>
-          <a:noFill/>
-          <a:ln/>
-        </p:spPr>
-        <p:txBody>
-          <a:bodyPr wrap="square" rtlCol="0" anchor="ctr"/>
-          <a:lstStyle/>
-          <a:p>
-            <a:pPr indent="0" marL="0">
-              <a:buNone/>
-            </a:pPr>
-            <a:r>
-              <a:rPr lang="en-US" sz="1180" i="1" dirty="0">
+            <a:off x="822960" y="5943600"/>
+            <a:ext cx="10515600" cy="548640"/>
+          </a:xfrm>
+          <a:prstGeom prst="rect">
+            <a:avLst/>
+          </a:prstGeom>
+          <a:noFill/>
+          <a:ln/>
+        </p:spPr>
+        <p:txBody>
+          <a:bodyPr wrap="square" rtlCol="0" anchor="ctr"/>
+          <a:lstStyle/>
+          <a:p>
+            <a:pPr indent="0" marL="0">
+              <a:buNone/>
+            </a:pPr>
+            <a:r>
+              <a:rPr lang="en-US" sz="1100" i="1" dirty="0">
                 <a:solidFill>
                   <a:srgbClr val="6E6A63"/>
                 </a:solidFill>
@@ -4000,9 +4000,9 @@
                 <a:ea typeface="Calibri" pitchFamily="34" charset="-122"/>
                 <a:cs typeface="Calibri" pitchFamily="34" charset="-120"/>
               </a:rPr>
-              <a:t>Las tres objeciones formuladas desde el área de contratación son la razón de ser de esta versión y están respondidas en el cuerpo del documento.</a:t>
-            </a:r>
-            <a:endParaRPr lang="en-US" sz="1180" dirty="0"/>
+              <a:t>La objeción interna de junio de 2026, con sus cuatro reproches, es la razón de ser de esta versión y está citada y respondida en el cuerpo del documento. Ningún órgano de contratación, intervención o asesoría jurídica se ha pronunciado sobre el catálogo.</a:t>
+            </a:r>
+            <a:endParaRPr lang="en-US" sz="1100" dirty="0"/>
           </a:p>
         </p:txBody>
       </p:sp>
@@ -7800,7 +7800,7 @@
                 <a:ea typeface="Georgia" pitchFamily="34" charset="-122"/>
                 <a:cs typeface="Georgia" pitchFamily="34" charset="-120"/>
               </a:rPr>
-              <a:t>De dónde sale: un ayuntamiento y tres objeciones</a:t>
+              <a:t>De dónde sale: un problema real y cuatro objeciones</a:t>
             </a:r>
             <a:endParaRPr lang="en-US" sz="3600" dirty="0"/>
           </a:p>
@@ -7839,7 +7839,7 @@
                 <a:ea typeface="Calibri" pitchFamily="34" charset="-122"/>
                 <a:cs typeface="Calibri" pitchFamily="34" charset="-120"/>
               </a:rPr>
-              <a:t>El clausulado nació en el Ayuntamiento de Pozuelo de Alarcón en 2026 y se sometió al criterio de su área de contratación. Lo que esa área respondió es lo que da forma a esta versión.</a:t>
+              <a:t>El clausulado nació en el Ayuntamiento de Pozuelo de Alarcón en 2026 y se sometió por escrito a la crítica de quien tendría que aplicarlo. Lo que esa crítica dijo es lo que da forma a esta versión.</a:t>
             </a:r>
             <a:endParaRPr lang="en-US" sz="1750" dirty="0"/>
           </a:p>
@@ -7853,12 +7853,12 @@
         </p:nvSpPr>
         <p:spPr>
           <a:xfrm>
-            <a:off x="822960" y="2377440"/>
-            <a:ext cx="10515600" cy="1051560"/>
+            <a:off x="822960" y="2240280"/>
+            <a:ext cx="10515600" cy="841248"/>
           </a:xfrm>
           <a:prstGeom prst="roundRect">
             <a:avLst>
-              <a:gd name="adj" fmla="val 8696"/>
+              <a:gd name="adj" fmla="val 10870"/>
             </a:avLst>
           </a:prstGeom>
           <a:solidFill>
@@ -7875,24 +7875,24 @@
         </p:nvSpPr>
         <p:spPr>
           <a:xfrm>
-            <a:off x="1051560" y="2468880"/>
-            <a:ext cx="2743200" cy="868680"/>
-          </a:xfrm>
-          <a:prstGeom prst="rect">
-            <a:avLst/>
-          </a:prstGeom>
-          <a:noFill/>
-          <a:ln/>
-        </p:spPr>
-        <p:txBody>
-          <a:bodyPr wrap="square" rtlCol="0" anchor="ctr"/>
-          <a:lstStyle/>
-          <a:p>
-            <a:pPr indent="0" marL="0">
-              <a:buNone/>
-            </a:pPr>
-            <a:r>
-              <a:rPr lang="en-US" sz="1700" b="1" dirty="0">
+            <a:off x="1051560" y="2295144"/>
+            <a:ext cx="2834640" cy="731520"/>
+          </a:xfrm>
+          <a:prstGeom prst="rect">
+            <a:avLst/>
+          </a:prstGeom>
+          <a:noFill/>
+          <a:ln/>
+        </p:spPr>
+        <p:txBody>
+          <a:bodyPr wrap="square" rtlCol="0" anchor="ctr"/>
+          <a:lstStyle/>
+          <a:p>
+            <a:pPr indent="0" marL="0">
+              <a:buNone/>
+            </a:pPr>
+            <a:r>
+              <a:rPr lang="en-US" sz="1450" b="1" dirty="0">
                 <a:solidFill>
                   <a:srgbClr val="1F3864"/>
                 </a:solidFill>
@@ -7902,7 +7902,7 @@
               </a:rPr>
               <a:t>«Artificioso al contrato»</a:t>
             </a:r>
-            <a:endParaRPr lang="en-US" sz="1700" dirty="0"/>
+            <a:endParaRPr lang="en-US" sz="1450" dirty="0"/>
           </a:p>
         </p:txBody>
       </p:sp>
@@ -7914,24 +7914,24 @@
         </p:nvSpPr>
         <p:spPr>
           <a:xfrm>
-            <a:off x="3931920" y="2468880"/>
-            <a:ext cx="7223760" cy="868680"/>
-          </a:xfrm>
-          <a:prstGeom prst="rect">
-            <a:avLst/>
-          </a:prstGeom>
-          <a:noFill/>
-          <a:ln/>
-        </p:spPr>
-        <p:txBody>
-          <a:bodyPr wrap="square" rtlCol="0" anchor="ctr"/>
-          <a:lstStyle/>
-          <a:p>
-            <a:pPr indent="0" marL="0">
-              <a:buNone/>
-            </a:pPr>
-            <a:r>
-              <a:rPr lang="en-US" sz="1450" dirty="0">
+            <a:off x="4023360" y="2295144"/>
+            <a:ext cx="7132320" cy="731520"/>
+          </a:xfrm>
+          <a:prstGeom prst="rect">
+            <a:avLst/>
+          </a:prstGeom>
+          <a:noFill/>
+          <a:ln/>
+        </p:spPr>
+        <p:txBody>
+          <a:bodyPr wrap="square" rtlCol="0" anchor="ctr"/>
+          <a:lstStyle/>
+          <a:p>
+            <a:pPr indent="0" marL="0">
+              <a:buNone/>
+            </a:pPr>
+            <a:r>
+              <a:rPr lang="en-US" sz="1200" dirty="0">
                 <a:solidFill>
                   <a:srgbClr val="22201D"/>
                 </a:solidFill>
@@ -7939,9 +7939,9 @@
                 <a:ea typeface="Calibri" pitchFamily="34" charset="-122"/>
                 <a:cs typeface="Calibri" pitchFamily="34" charset="-120"/>
               </a:rPr>
-              <a:t>Cada cláusula lleva ahora el origen de su necesidad: una norma, el servicio gestor, o un acuerdo del órgano de gobierno. Lo que no tiene ninguno de los tres, no entra.</a:t>
-            </a:r>
-            <a:endParaRPr lang="en-US" sz="1450" dirty="0"/>
+              <a:t>Cada cláusula lleva el origen de su necesidad: una norma, el servicio gestor, o un acuerdo del órgano de gobierno. Lo que no tiene ninguno de los tres, no entra.</a:t>
+            </a:r>
+            <a:endParaRPr lang="en-US" sz="1200" dirty="0"/>
           </a:p>
         </p:txBody>
       </p:sp>
@@ -7953,12 +7953,12 @@
         </p:nvSpPr>
         <p:spPr>
           <a:xfrm>
-            <a:off x="822960" y="3611880"/>
-            <a:ext cx="10515600" cy="1051560"/>
+            <a:off x="822960" y="3172968"/>
+            <a:ext cx="10515600" cy="841248"/>
           </a:xfrm>
           <a:prstGeom prst="roundRect">
             <a:avLst>
-              <a:gd name="adj" fmla="val 8696"/>
+              <a:gd name="adj" fmla="val 10870"/>
             </a:avLst>
           </a:prstGeom>
           <a:solidFill>
@@ -7975,24 +7975,24 @@
         </p:nvSpPr>
         <p:spPr>
           <a:xfrm>
-            <a:off x="1051560" y="3703320"/>
-            <a:ext cx="2743200" cy="868680"/>
-          </a:xfrm>
-          <a:prstGeom prst="rect">
-            <a:avLst/>
-          </a:prstGeom>
-          <a:noFill/>
-          <a:ln/>
-        </p:spPr>
-        <p:txBody>
-          <a:bodyPr wrap="square" rtlCol="0" anchor="ctr"/>
-          <a:lstStyle/>
-          <a:p>
-            <a:pPr indent="0" marL="0">
-              <a:buNone/>
-            </a:pPr>
-            <a:r>
-              <a:rPr lang="en-US" sz="1700" b="1" dirty="0">
+            <a:off x="1051560" y="3227832"/>
+            <a:ext cx="2834640" cy="731520"/>
+          </a:xfrm>
+          <a:prstGeom prst="rect">
+            <a:avLst/>
+          </a:prstGeom>
+          <a:noFill/>
+          <a:ln/>
+        </p:spPr>
+        <p:txBody>
+          <a:bodyPr wrap="square" rtlCol="0" anchor="ctr"/>
+          <a:lstStyle/>
+          <a:p>
+            <a:pPr indent="0" marL="0">
+              <a:buNone/>
+            </a:pPr>
+            <a:r>
+              <a:rPr lang="en-US" sz="1450" b="1" dirty="0">
                 <a:solidFill>
                   <a:srgbClr val="1F3864"/>
                 </a:solidFill>
@@ -8000,9 +8000,9 @@
                 <a:ea typeface="Georgia" pitchFamily="34" charset="-122"/>
                 <a:cs typeface="Georgia" pitchFamily="34" charset="-120"/>
               </a:rPr>
-              <a:t>«Demasiado abstracto»</a:t>
-            </a:r>
-            <a:endParaRPr lang="en-US" sz="1700" dirty="0"/>
+              <a:t>«El seguimiento real es escaso»</a:t>
+            </a:r>
+            <a:endParaRPr lang="en-US" sz="1450" dirty="0"/>
           </a:p>
         </p:txBody>
       </p:sp>
@@ -8014,24 +8014,24 @@
         </p:nvSpPr>
         <p:spPr>
           <a:xfrm>
-            <a:off x="3931920" y="3703320"/>
-            <a:ext cx="7223760" cy="868680"/>
-          </a:xfrm>
-          <a:prstGeom prst="rect">
-            <a:avLst/>
-          </a:prstGeom>
-          <a:noFill/>
-          <a:ln/>
-        </p:spPr>
-        <p:txBody>
-          <a:bodyPr wrap="square" rtlCol="0" anchor="ctr"/>
-          <a:lstStyle/>
-          <a:p>
-            <a:pPr indent="0" marL="0">
-              <a:buNone/>
-            </a:pPr>
-            <a:r>
-              <a:rPr lang="en-US" sz="1450" dirty="0">
+            <a:off x="4023360" y="3227832"/>
+            <a:ext cx="7132320" cy="731520"/>
+          </a:xfrm>
+          <a:prstGeom prst="rect">
+            <a:avLst/>
+          </a:prstGeom>
+          <a:noFill/>
+          <a:ln/>
+        </p:spPr>
+        <p:txBody>
+          <a:bodyPr wrap="square" rtlCol="0" anchor="ctr"/>
+          <a:lstStyle/>
+          <a:p>
+            <a:pPr indent="0" marL="0">
+              <a:buNone/>
+            </a:pPr>
+            <a:r>
+              <a:rPr lang="en-US" sz="1200" dirty="0">
                 <a:solidFill>
                   <a:srgbClr val="22201D"/>
                 </a:solidFill>
@@ -8039,9 +8039,9 @@
                 <a:ea typeface="Calibri" pitchFamily="34" charset="-122"/>
                 <a:cs typeface="Calibri" pitchFamily="34" charset="-120"/>
               </a:rPr>
-              <a:t>Cada cláusula tiene siete epígrafes fijos, y el texto que se copia va dentro de un recuadro. Fuera del recuadro no se copia nada.</a:t>
-            </a:r>
-            <a:endParaRPr lang="en-US" sz="1450" dirty="0"/>
+              <a:t>Quien controla no puede imponer instrumentos, pero sí necesita el dato al mismo rango que quien gestiona. De ahí ADM-12: sin tarificar, en formato abierto y con diccionario de datos.</a:t>
+            </a:r>
+            <a:endParaRPr lang="en-US" sz="1200" dirty="0"/>
           </a:p>
         </p:txBody>
       </p:sp>
@@ -8053,12 +8053,12 @@
         </p:nvSpPr>
         <p:spPr>
           <a:xfrm>
-            <a:off x="822960" y="4846320"/>
-            <a:ext cx="10515600" cy="1051560"/>
+            <a:off x="822960" y="4105656"/>
+            <a:ext cx="10515600" cy="841248"/>
           </a:xfrm>
           <a:prstGeom prst="roundRect">
             <a:avLst>
-              <a:gd name="adj" fmla="val 8696"/>
+              <a:gd name="adj" fmla="val 10870"/>
             </a:avLst>
           </a:prstGeom>
           <a:solidFill>
@@ -8075,24 +8075,24 @@
         </p:nvSpPr>
         <p:spPr>
           <a:xfrm>
-            <a:off x="1051560" y="4937760"/>
-            <a:ext cx="2743200" cy="868680"/>
-          </a:xfrm>
-          <a:prstGeom prst="rect">
-            <a:avLst/>
-          </a:prstGeom>
-          <a:noFill/>
-          <a:ln/>
-        </p:spPr>
-        <p:txBody>
-          <a:bodyPr wrap="square" rtlCol="0" anchor="ctr"/>
-          <a:lstStyle/>
-          <a:p>
-            <a:pPr indent="0" marL="0">
-              <a:buNone/>
-            </a:pPr>
-            <a:r>
-              <a:rPr lang="en-US" sz="1700" b="1" dirty="0">
+            <a:off x="1051560" y="4160520"/>
+            <a:ext cx="2834640" cy="731520"/>
+          </a:xfrm>
+          <a:prstGeom prst="rect">
+            <a:avLst/>
+          </a:prstGeom>
+          <a:noFill/>
+          <a:ln/>
+        </p:spPr>
+        <p:txBody>
+          <a:bodyPr wrap="square" rtlCol="0" anchor="ctr"/>
+          <a:lstStyle/>
+          <a:p>
+            <a:pPr indent="0" marL="0">
+              <a:buNone/>
+            </a:pPr>
+            <a:r>
+              <a:rPr lang="en-US" sz="1450" b="1" dirty="0">
                 <a:solidFill>
                   <a:srgbClr val="1F3864"/>
                 </a:solidFill>
@@ -8100,9 +8100,9 @@
                 <a:ea typeface="Georgia" pitchFamily="34" charset="-122"/>
                 <a:cs typeface="Georgia" pitchFamily="34" charset="-120"/>
               </a:rPr>
-              <a:t>«Pruébalo primero»</a:t>
-            </a:r>
-            <a:endParaRPr lang="en-US" sz="1700" dirty="0"/>
+              <a:t>«Demasiado abstracto»</a:t>
+            </a:r>
+            <a:endParaRPr lang="en-US" sz="1450" dirty="0"/>
           </a:p>
         </p:txBody>
       </p:sp>
@@ -8114,24 +8114,24 @@
         </p:nvSpPr>
         <p:spPr>
           <a:xfrm>
-            <a:off x="3931920" y="4937760"/>
-            <a:ext cx="7223760" cy="868680"/>
-          </a:xfrm>
-          <a:prstGeom prst="rect">
-            <a:avLst/>
-          </a:prstGeom>
-          <a:noFill/>
-          <a:ln/>
-        </p:spPr>
-        <p:txBody>
-          <a:bodyPr wrap="square" rtlCol="0" anchor="ctr"/>
-          <a:lstStyle/>
-          <a:p>
-            <a:pPr indent="0" marL="0">
-              <a:buNone/>
-            </a:pPr>
-            <a:r>
-              <a:rPr lang="en-US" sz="1450" dirty="0">
+            <a:off x="4023360" y="4160520"/>
+            <a:ext cx="7132320" cy="731520"/>
+          </a:xfrm>
+          <a:prstGeom prst="rect">
+            <a:avLst/>
+          </a:prstGeom>
+          <a:noFill/>
+          <a:ln/>
+        </p:spPr>
+        <p:txBody>
+          <a:bodyPr wrap="square" rtlCol="0" anchor="ctr"/>
+          <a:lstStyle/>
+          <a:p>
+            <a:pPr indent="0" marL="0">
+              <a:buNone/>
+            </a:pPr>
+            <a:r>
+              <a:rPr lang="en-US" sz="1200" dirty="0">
                 <a:solidFill>
                   <a:srgbClr val="22201D"/>
                 </a:solidFill>
@@ -8139,7 +8139,68 @@
                 <a:ea typeface="Calibri" pitchFamily="34" charset="-122"/>
                 <a:cs typeface="Calibri" pitchFamily="34" charset="-120"/>
               </a:rPr>
-              <a:t>El documento incluye el caso piloto resuelto entero, con su expediente y con lo que hay que rectificar de lo ya redactado.</a:t>
+              <a:t>Método para elegir el contrato piloto, y un subconjunto mínimo de seis cláusulas para empezar. El catálogo entero no entra en el primer expediente.</a:t>
+            </a:r>
+            <a:endParaRPr lang="en-US" sz="1200" dirty="0"/>
+          </a:p>
+        </p:txBody>
+      </p:sp>
+      <p:sp>
+        <p:nvSpPr>
+          <p:cNvPr id="13" name="Shape 11"/>
+          <p:cNvSpPr/>
+          <p:nvPr/>
+        </p:nvSpPr>
+        <p:spPr>
+          <a:xfrm>
+            <a:off x="822960" y="5038344"/>
+            <a:ext cx="10515600" cy="841248"/>
+          </a:xfrm>
+          <a:prstGeom prst="roundRect">
+            <a:avLst>
+              <a:gd name="adj" fmla="val 10870"/>
+            </a:avLst>
+          </a:prstGeom>
+          <a:solidFill>
+            <a:srgbClr val="FFFFFF"/>
+          </a:solidFill>
+          <a:ln/>
+        </p:spPr>
+      </p:sp>
+      <p:sp>
+        <p:nvSpPr>
+          <p:cNvPr id="14" name="Text 12"/>
+          <p:cNvSpPr/>
+          <p:nvPr/>
+        </p:nvSpPr>
+        <p:spPr>
+          <a:xfrm>
+            <a:off x="1051560" y="5093208"/>
+            <a:ext cx="2834640" cy="731520"/>
+          </a:xfrm>
+          <a:prstGeom prst="rect">
+            <a:avLst/>
+          </a:prstGeom>
+          <a:noFill/>
+          <a:ln/>
+        </p:spPr>
+        <p:txBody>
+          <a:bodyPr wrap="square" rtlCol="0" anchor="ctr"/>
+          <a:lstStyle/>
+          <a:p>
+            <a:pPr indent="0" marL="0">
+              <a:buNone/>
+            </a:pPr>
+            <a:r>
+              <a:rPr lang="en-US" sz="1450" b="1" dirty="0">
+                <a:solidFill>
+                  <a:srgbClr val="1F3864"/>
+                </a:solidFill>
+                <a:latin typeface="Georgia" pitchFamily="34" charset="0"/>
+                <a:ea typeface="Georgia" pitchFamily="34" charset="-122"/>
+                <a:cs typeface="Georgia" pitchFamily="34" charset="-120"/>
+              </a:rPr>
+              <a:t>«Hay actores que no lo han visto»</a:t>
             </a:r>
             <a:endParaRPr lang="en-US" sz="1450" dirty="0"/>
           </a:p>
@@ -8147,38 +8208,77 @@
       </p:sp>
       <p:sp>
         <p:nvSpPr>
-          <p:cNvPr id="13" name="Text 11"/>
-          <p:cNvSpPr/>
-          <p:nvPr/>
-        </p:nvSpPr>
-        <p:spPr>
-          <a:xfrm>
-            <a:off x="822960" y="5989320"/>
-            <a:ext cx="10515600" cy="548640"/>
-          </a:xfrm>
-          <a:prstGeom prst="rect">
-            <a:avLst/>
-          </a:prstGeom>
-          <a:noFill/>
-          <a:ln/>
-        </p:spPr>
-        <p:txBody>
-          <a:bodyPr wrap="square" rtlCol="0" anchor="ctr"/>
-          <a:lstStyle/>
-          <a:p>
-            <a:pPr indent="0" marL="0">
-              <a:buNone/>
-            </a:pPr>
-            <a:r>
-              <a:rPr lang="en-US" sz="1400" i="1" dirty="0">
-                <a:solidFill>
-                  <a:srgbClr val="6E6A63"/>
+          <p:cNvPr id="15" name="Text 13"/>
+          <p:cNvSpPr/>
+          <p:nvPr/>
+        </p:nvSpPr>
+        <p:spPr>
+          <a:xfrm>
+            <a:off x="4023360" y="5093208"/>
+            <a:ext cx="7132320" cy="731520"/>
+          </a:xfrm>
+          <a:prstGeom prst="rect">
+            <a:avLst/>
+          </a:prstGeom>
+          <a:noFill/>
+          <a:ln/>
+        </p:spPr>
+        <p:txBody>
+          <a:bodyPr wrap="square" rtlCol="0" anchor="ctr"/>
+          <a:lstStyle/>
+          <a:p>
+            <a:pPr indent="0" marL="0">
+              <a:buNone/>
+            </a:pPr>
+            <a:r>
+              <a:rPr lang="en-US" sz="1200" dirty="0">
+                <a:solidFill>
+                  <a:srgbClr val="22201D"/>
                 </a:solidFill>
                 <a:latin typeface="Calibri" pitchFamily="34" charset="0"/>
                 <a:ea typeface="Calibri" pitchFamily="34" charset="-122"/>
                 <a:cs typeface="Calibri" pitchFamily="34" charset="-120"/>
               </a:rPr>
-              <a:t>Las tres objeciones se responden dentro del documento, no en una nota al pie.</a:t>
+              <a:t>Consulta preliminar anual, publicación del Anexo V antes de licitar, plazo por encima del mínimo y gradualidad. Si el mercado no puede cumplirlo, la exigencia no entra en el pliego.</a:t>
+            </a:r>
+            <a:endParaRPr lang="en-US" sz="1200" dirty="0"/>
+          </a:p>
+        </p:txBody>
+      </p:sp>
+      <p:sp>
+        <p:nvSpPr>
+          <p:cNvPr id="16" name="Text 14"/>
+          <p:cNvSpPr/>
+          <p:nvPr/>
+        </p:nvSpPr>
+        <p:spPr>
+          <a:xfrm>
+            <a:off x="822960" y="5989320"/>
+            <a:ext cx="10515600" cy="548640"/>
+          </a:xfrm>
+          <a:prstGeom prst="rect">
+            <a:avLst/>
+          </a:prstGeom>
+          <a:noFill/>
+          <a:ln/>
+        </p:spPr>
+        <p:txBody>
+          <a:bodyPr wrap="square" rtlCol="0" anchor="ctr"/>
+          <a:lstStyle/>
+          <a:p>
+            <a:pPr indent="0" marL="0">
+              <a:buNone/>
+            </a:pPr>
+            <a:r>
+              <a:rPr lang="en-US" sz="1400" i="1" dirty="0">
+                <a:solidFill>
+                  <a:srgbClr val="6E6A63"/>
+                </a:solidFill>
+                <a:latin typeface="Calibri" pitchFamily="34" charset="0"/>
+                <a:ea typeface="Calibri" pitchFamily="34" charset="-122"/>
+                <a:cs typeface="Calibri" pitchFamily="34" charset="-120"/>
+              </a:rPr>
+              <a:t>Las cuatro objeciones se citan enteras y se responden dentro del documento, no en una nota al pie.</a:t>
             </a:r>
             <a:endParaRPr lang="en-US" sz="1400" dirty="0"/>
           </a:p>

</xml_diff>